<commit_message>
📄 Add plan file: plan_37.pptx
</commit_message>
<xml_diff>
--- a/plans/plan_37.pptx
+++ b/plans/plan_37.pptx
@@ -3183,7 +3183,7 @@
                 <a:solidFill>
                   <a:srgbClr val="FFFFFF"/>
                 </a:solidFill>
-                <a:latin typeface="WenQuanYi Micro Hei"/>
+                <a:latin typeface="Microsoft YaHei"/>
               </a:rPr>
               <a:t>蜀香坊火锅</a:t>
             </a:r>
@@ -3218,7 +3218,7 @@
                 <a:solidFill>
                   <a:srgbClr val="90CAF9"/>
                 </a:solidFill>
-                <a:latin typeface="WenQuanYi Micro Hei"/>
+                <a:latin typeface="Microsoft YaHei"/>
               </a:rPr>
               <a:t>数字化经营解决方案 · 储值锁客+工作日引流专项</a:t>
             </a:r>
@@ -3253,7 +3253,7 @@
                 <a:solidFill>
                   <a:srgbClr val="90CAF9"/>
                 </a:solidFill>
-                <a:latin typeface="WenQuanYi Micro Hei"/>
+                <a:latin typeface="Microsoft YaHei"/>
               </a:rPr>
               <a:t>美团收银 | 会员营销旗舰版 | 全域运营方案</a:t>
             </a:r>
@@ -3288,7 +3288,7 @@
                 <a:solidFill>
                   <a:srgbClr val="789EC9"/>
                 </a:solidFill>
-                <a:latin typeface="WenQuanYi Micro Hei"/>
+                <a:latin typeface="Microsoft YaHei"/>
               </a:rPr>
               <a:t>2026年5月 · 杭州萧山</a:t>
             </a:r>
@@ -3393,7 +3393,7 @@
                 <a:solidFill>
                   <a:srgbClr val="FFFFFF"/>
                 </a:solidFill>
-                <a:latin typeface="WenQuanYi Micro Hei"/>
+                <a:latin typeface="Microsoft YaHei"/>
               </a:rPr>
               <a:t>🎯 OKR量化目标（3个月）</a:t>
             </a:r>
@@ -3428,7 +3428,7 @@
                 <a:solidFill>
                   <a:srgbClr val="BBDEFB"/>
                 </a:solidFill>
-                <a:latin typeface="WenQuanYi Micro Hei"/>
+                <a:latin typeface="Microsoft YaHei"/>
               </a:rPr>
               <a:t>可衡量 · 可追踪 · 可复盘</a:t>
             </a:r>
@@ -3467,7 +3467,7 @@
                 <a:solidFill>
                   <a:srgbClr val="333333"/>
                 </a:solidFill>
-                <a:latin typeface="WenQuanYi Micro Hei"/>
+                <a:latin typeface="Microsoft YaHei"/>
               </a:rPr>
               <a:t>━━━━━━━━━━━━━━━━━━━━━━━━━━━━━━━━━━━━━━━━━━━━━━━━━</a:t>
             </a:r>
@@ -3483,7 +3483,7 @@
                 <a:solidFill>
                   <a:srgbClr val="333333"/>
                 </a:solidFill>
-                <a:latin typeface="WenQuanYi Micro Hei"/>
+                <a:latin typeface="Microsoft YaHei"/>
               </a:rPr>
               <a:t/>
             </a:r>
@@ -3499,7 +3499,7 @@
                 <a:solidFill>
                   <a:srgbClr val="333333"/>
                 </a:solidFill>
-                <a:latin typeface="WenQuanYi Micro Hei"/>
+                <a:latin typeface="Microsoft YaHei"/>
               </a:rPr>
               <a:t>O1: 月营收从¥450,000提升至¥520,000（+¥70,000/月，+15.6%）</a:t>
             </a:r>
@@ -3515,7 +3515,7 @@
                 <a:solidFill>
                   <a:srgbClr val="333333"/>
                 </a:solidFill>
-                <a:latin typeface="WenQuanYi Micro Hei"/>
+                <a:latin typeface="Microsoft YaHei"/>
               </a:rPr>
               <a:t>    KR1: 储值释放月增收 +¥30,000（80笔×主推¥1,000档×回流消费）</a:t>
             </a:r>
@@ -3531,7 +3531,7 @@
                 <a:solidFill>
                   <a:srgbClr val="333333"/>
                 </a:solidFill>
-                <a:latin typeface="WenQuanYi Micro Hei"/>
+                <a:latin typeface="Microsoft YaHei"/>
               </a:rPr>
               <a:t>    KR2: 工作日引流月增收 +¥28,000（日均+25人×¥110×22天×46%毛利转化）</a:t>
             </a:r>
@@ -3547,7 +3547,7 @@
                 <a:solidFill>
                   <a:srgbClr val="333333"/>
                 </a:solidFill>
-                <a:latin typeface="WenQuanYi Micro Hei"/>
+                <a:latin typeface="Microsoft YaHei"/>
               </a:rPr>
               <a:t>    KR3: 公域新客月增收 +¥12,000（月新增100新客×¥110×首次+复购转化）</a:t>
             </a:r>
@@ -3563,7 +3563,7 @@
                 <a:solidFill>
                   <a:srgbClr val="333333"/>
                 </a:solidFill>
-                <a:latin typeface="WenQuanYi Micro Hei"/>
+                <a:latin typeface="Microsoft YaHei"/>
               </a:rPr>
               <a:t/>
             </a:r>
@@ -3579,7 +3579,7 @@
                 <a:solidFill>
                   <a:srgbClr val="333333"/>
                 </a:solidFill>
-                <a:latin typeface="WenQuanYi Micro Hei"/>
+                <a:latin typeface="Microsoft YaHei"/>
               </a:rPr>
               <a:t>O2: 会员/储值核心指标</a:t>
             </a:r>
@@ -3595,7 +3595,7 @@
                 <a:solidFill>
                   <a:srgbClr val="333333"/>
                 </a:solidFill>
-                <a:latin typeface="WenQuanYi Micro Hei"/>
+                <a:latin typeface="Microsoft YaHei"/>
               </a:rPr>
               <a:t>    KR1: 月新增储值80笔，储值余额池达¥200,000</a:t>
             </a:r>
@@ -3611,7 +3611,7 @@
                 <a:solidFill>
                   <a:srgbClr val="333333"/>
                 </a:solidFill>
-                <a:latin typeface="WenQuanYi Micro Hei"/>
+                <a:latin typeface="Microsoft YaHei"/>
               </a:rPr>
               <a:t>    KR2: 储值客占比从&lt;15%提升至30%+</a:t>
             </a:r>
@@ -3627,7 +3627,7 @@
                 <a:solidFill>
                   <a:srgbClr val="333333"/>
                 </a:solidFill>
-                <a:latin typeface="WenQuanYi Micro Hei"/>
+                <a:latin typeface="Microsoft YaHei"/>
               </a:rPr>
               <a:t>    KR3: 会员总数从0增至2,000+（扫码自动入会）</a:t>
             </a:r>
@@ -3643,7 +3643,7 @@
                 <a:solidFill>
                   <a:srgbClr val="333333"/>
                 </a:solidFill>
-                <a:latin typeface="WenQuanYi Micro Hei"/>
+                <a:latin typeface="Microsoft YaHei"/>
               </a:rPr>
               <a:t>    KR4: 沉睡会员(&gt;15天)唤醒率 ≥ 20%</a:t>
             </a:r>
@@ -3659,7 +3659,7 @@
                 <a:solidFill>
                   <a:srgbClr val="333333"/>
                 </a:solidFill>
-                <a:latin typeface="WenQuanYi Micro Hei"/>
+                <a:latin typeface="Microsoft YaHei"/>
               </a:rPr>
               <a:t/>
             </a:r>
@@ -3675,7 +3675,7 @@
                 <a:solidFill>
                   <a:srgbClr val="333333"/>
                 </a:solidFill>
-                <a:latin typeface="WenQuanYi Micro Hei"/>
+                <a:latin typeface="Microsoft YaHei"/>
               </a:rPr>
               <a:t>O3: 品牌线上影响力</a:t>
             </a:r>
@@ -3691,7 +3691,7 @@
                 <a:solidFill>
                   <a:srgbClr val="333333"/>
                 </a:solidFill>
-                <a:latin typeface="WenQuanYi Micro Hei"/>
+                <a:latin typeface="Microsoft YaHei"/>
               </a:rPr>
               <a:t>    KR1: 大众点评评分维持/提升至4.5+</a:t>
             </a:r>
@@ -3707,7 +3707,7 @@
                 <a:solidFill>
                   <a:srgbClr val="333333"/>
                 </a:solidFill>
-                <a:latin typeface="WenQuanYi Micro Hei"/>
+                <a:latin typeface="Microsoft YaHei"/>
               </a:rPr>
               <a:t>    KR2: 月新增优质评价30条+</a:t>
             </a:r>
@@ -3723,7 +3723,7 @@
                 <a:solidFill>
                   <a:srgbClr val="333333"/>
                 </a:solidFill>
-                <a:latin typeface="WenQuanYi Micro Hei"/>
+                <a:latin typeface="Microsoft YaHei"/>
               </a:rPr>
               <a:t>    KR3: 小红书笔记累计12篇，搜索「萧山火锅」前5可见</a:t>
             </a:r>
@@ -3739,7 +3739,7 @@
                 <a:solidFill>
                   <a:srgbClr val="333333"/>
                 </a:solidFill>
-                <a:latin typeface="WenQuanYi Micro Hei"/>
+                <a:latin typeface="Microsoft YaHei"/>
               </a:rPr>
               <a:t/>
             </a:r>
@@ -3755,7 +3755,7 @@
                 <a:solidFill>
                   <a:srgbClr val="333333"/>
                 </a:solidFill>
-                <a:latin typeface="WenQuanYi Micro Hei"/>
+                <a:latin typeface="Microsoft YaHei"/>
               </a:rPr>
               <a:t>━━━━━━━━━━━━━━━━━━━━━━━━━━━━━━━━━━━━━━━━━━━━━━━━━</a:t>
             </a:r>
@@ -3771,7 +3771,7 @@
                 <a:solidFill>
                   <a:srgbClr val="333333"/>
                 </a:solidFill>
-                <a:latin typeface="WenQuanYi Micro Hei"/>
+                <a:latin typeface="Microsoft YaHei"/>
               </a:rPr>
               <a:t/>
             </a:r>
@@ -3787,7 +3787,7 @@
                 <a:solidFill>
                   <a:srgbClr val="333333"/>
                 </a:solidFill>
-                <a:latin typeface="WenQuanYi Micro Hei"/>
+                <a:latin typeface="Microsoft YaHei"/>
               </a:rPr>
               <a:t>💡 数字校验：月增收¥70,000 = 储值¥30K + 工作日¥28K + 新客¥12K ✅</a:t>
             </a:r>
@@ -3892,7 +3892,7 @@
                 <a:solidFill>
                   <a:srgbClr val="FFFFFF"/>
                 </a:solidFill>
-                <a:latin typeface="WenQuanYi Micro Hei"/>
+                <a:latin typeface="Microsoft YaHei"/>
               </a:rPr>
               <a:t>💰 投资回报分析</a:t>
             </a:r>
@@ -3927,7 +3927,7 @@
                 <a:solidFill>
                   <a:srgbClr val="BBDEFB"/>
                 </a:solidFill>
-                <a:latin typeface="WenQuanYi Micro Hei"/>
+                <a:latin typeface="Microsoft YaHei"/>
               </a:rPr>
               <a:t>花多少 · 赚多少 · 多久回本</a:t>
             </a:r>
@@ -3962,7 +3962,7 @@
                 <a:solidFill>
                   <a:srgbClr val="0D47A1"/>
                 </a:solidFill>
-                <a:latin typeface="WenQuanYi Micro Hei"/>
+                <a:latin typeface="Microsoft YaHei"/>
               </a:rPr>
               <a:t>📋 已签约SaaS产品（年费已含）</a:t>
             </a:r>
@@ -4001,7 +4001,7 @@
                 <a:solidFill>
                   <a:srgbClr val="333333"/>
                 </a:solidFill>
-                <a:latin typeface="WenQuanYi Micro Hei"/>
+                <a:latin typeface="Microsoft YaHei"/>
               </a:rPr>
               <a:t>智能收银系统         已签约（含在现有合同中）</a:t>
             </a:r>
@@ -4017,7 +4017,7 @@
                 <a:solidFill>
                   <a:srgbClr val="333333"/>
                 </a:solidFill>
-                <a:latin typeface="WenQuanYi Micro Hei"/>
+                <a:latin typeface="Microsoft YaHei"/>
               </a:rPr>
               <a:t>会员营销旗舰版       ¥4,888/年 ← 已签约</a:t>
             </a:r>
@@ -4033,7 +4033,7 @@
                 <a:solidFill>
                   <a:srgbClr val="333333"/>
                 </a:solidFill>
-                <a:latin typeface="WenQuanYi Micro Hei"/>
+                <a:latin typeface="Microsoft YaHei"/>
               </a:rPr>
               <a:t>美团外卖接入         已签约</a:t>
             </a:r>
@@ -4049,7 +4049,7 @@
                 <a:solidFill>
                   <a:srgbClr val="333333"/>
                 </a:solidFill>
-                <a:latin typeface="WenQuanYi Micro Hei"/>
+                <a:latin typeface="Microsoft YaHei"/>
               </a:rPr>
               <a:t>在线预订             已签约</a:t>
             </a:r>
@@ -4065,7 +4065,7 @@
                 <a:solidFill>
                   <a:srgbClr val="333333"/>
                 </a:solidFill>
-                <a:latin typeface="WenQuanYi Micro Hei"/>
+                <a:latin typeface="Microsoft YaHei"/>
               </a:rPr>
               <a:t>储值套餐             已签约</a:t>
             </a:r>
@@ -4081,7 +4081,7 @@
                 <a:solidFill>
                   <a:srgbClr val="333333"/>
                 </a:solidFill>
-                <a:latin typeface="WenQuanYi Micro Hei"/>
+                <a:latin typeface="Microsoft YaHei"/>
               </a:rPr>
               <a:t/>
             </a:r>
@@ -4097,7 +4097,7 @@
                 <a:solidFill>
                   <a:srgbClr val="333333"/>
                 </a:solidFill>
-                <a:latin typeface="WenQuanYi Micro Hei"/>
+                <a:latin typeface="Microsoft YaHei"/>
               </a:rPr>
               <a:t>📋 新增运营成本（月度）</a:t>
             </a:r>
@@ -4113,7 +4113,7 @@
                 <a:solidFill>
                   <a:srgbClr val="333333"/>
                 </a:solidFill>
-                <a:latin typeface="WenQuanYi Micro Hei"/>
+                <a:latin typeface="Microsoft YaHei"/>
               </a:rPr>
               <a:t>大众点评推广通       ¥1,500/月</a:t>
             </a:r>
@@ -4129,7 +4129,7 @@
                 <a:solidFill>
                   <a:srgbClr val="333333"/>
                 </a:solidFill>
-                <a:latin typeface="WenQuanYi Micro Hei"/>
+                <a:latin typeface="Microsoft YaHei"/>
               </a:rPr>
               <a:t>小红书KOC探店       ¥800/月（4位×¥200餐费）</a:t>
             </a:r>
@@ -4145,7 +4145,7 @@
                 <a:solidFill>
                   <a:srgbClr val="333333"/>
                 </a:solidFill>
-                <a:latin typeface="WenQuanYi Micro Hei"/>
+                <a:latin typeface="Microsoft YaHei"/>
               </a:rPr>
               <a:t>周三火锅日锅底折扣   ¥500/月（约40桌×¥12让利）</a:t>
             </a:r>
@@ -4161,7 +4161,7 @@
                 <a:solidFill>
                   <a:srgbClr val="333333"/>
                 </a:solidFill>
-                <a:latin typeface="WenQuanYi Micro Hei"/>
+                <a:latin typeface="Microsoft YaHei"/>
               </a:rPr>
               <a:t>储值赠送成本         ¥2,600/月（80笔×¥1000×13%赠送率）</a:t>
             </a:r>
@@ -4177,7 +4177,7 @@
                 <a:solidFill>
                   <a:srgbClr val="333333"/>
                 </a:solidFill>
-                <a:latin typeface="WenQuanYi Micro Hei"/>
+                <a:latin typeface="Microsoft YaHei"/>
               </a:rPr>
               <a:t>沉睡唤醒券核销       ¥600/月（约20张×¥30）</a:t>
             </a:r>
@@ -4193,7 +4193,7 @@
                 <a:solidFill>
                   <a:srgbClr val="333333"/>
                 </a:solidFill>
-                <a:latin typeface="WenQuanYi Micro Hei"/>
+                <a:latin typeface="Microsoft YaHei"/>
               </a:rPr>
               <a:t>─────────────────────────────</a:t>
             </a:r>
@@ -4209,7 +4209,7 @@
                 <a:solidFill>
                   <a:srgbClr val="333333"/>
                 </a:solidFill>
-                <a:latin typeface="WenQuanYi Micro Hei"/>
+                <a:latin typeface="Microsoft YaHei"/>
               </a:rPr>
               <a:t>月度运营总成本       ¥6,000/月</a:t>
             </a:r>
@@ -4244,7 +4244,7 @@
                 <a:solidFill>
                   <a:srgbClr val="0D47A1"/>
                 </a:solidFill>
-                <a:latin typeface="WenQuanYi Micro Hei"/>
+                <a:latin typeface="Microsoft YaHei"/>
               </a:rPr>
               <a:t>📈 月增收测算</a:t>
             </a:r>
@@ -4283,7 +4283,7 @@
                 <a:solidFill>
                   <a:srgbClr val="333333"/>
                 </a:solidFill>
-                <a:latin typeface="WenQuanYi Micro Hei"/>
+                <a:latin typeface="Microsoft YaHei"/>
               </a:rPr>
               <a:t>储值锁客带动复购增收    +¥30,000/月</a:t>
             </a:r>
@@ -4299,7 +4299,7 @@
                 <a:solidFill>
                   <a:srgbClr val="333333"/>
                 </a:solidFill>
-                <a:latin typeface="WenQuanYi Micro Hei"/>
+                <a:latin typeface="Microsoft YaHei"/>
               </a:rPr>
               <a:t>  (储值客月均2.5次 vs 非储值0.8次，增量1.7次×80人×¥110×20%渗透)</a:t>
             </a:r>
@@ -4315,7 +4315,7 @@
                 <a:solidFill>
                   <a:srgbClr val="333333"/>
                 </a:solidFill>
-                <a:latin typeface="WenQuanYi Micro Hei"/>
+                <a:latin typeface="Microsoft YaHei"/>
               </a:rPr>
               <a:t/>
             </a:r>
@@ -4331,7 +4331,7 @@
                 <a:solidFill>
                   <a:srgbClr val="333333"/>
                 </a:solidFill>
-                <a:latin typeface="WenQuanYi Micro Hei"/>
+                <a:latin typeface="Microsoft YaHei"/>
               </a:rPr>
               <a:t>工作日引流增收          +¥28,000/月</a:t>
             </a:r>
@@ -4347,7 +4347,7 @@
                 <a:solidFill>
                   <a:srgbClr val="333333"/>
                 </a:solidFill>
-                <a:latin typeface="WenQuanYi Micro Hei"/>
+                <a:latin typeface="Microsoft YaHei"/>
               </a:rPr>
               <a:t>  (日均+25人×¥110×22工作日×46%净增转化)</a:t>
             </a:r>
@@ -4363,7 +4363,7 @@
                 <a:solidFill>
                   <a:srgbClr val="333333"/>
                 </a:solidFill>
-                <a:latin typeface="WenQuanYi Micro Hei"/>
+                <a:latin typeface="Microsoft YaHei"/>
               </a:rPr>
               <a:t/>
             </a:r>
@@ -4379,7 +4379,7 @@
                 <a:solidFill>
                   <a:srgbClr val="333333"/>
                 </a:solidFill>
-                <a:latin typeface="WenQuanYi Micro Hei"/>
+                <a:latin typeface="Microsoft YaHei"/>
               </a:rPr>
               <a:t>公域新客增收            +¥12,000/月</a:t>
             </a:r>
@@ -4395,7 +4395,7 @@
                 <a:solidFill>
                   <a:srgbClr val="333333"/>
                 </a:solidFill>
-                <a:latin typeface="WenQuanYi Micro Hei"/>
+                <a:latin typeface="Microsoft YaHei"/>
               </a:rPr>
               <a:t>  (月新增100新客×¥110×首次+15%复购转化)</a:t>
             </a:r>
@@ -4411,7 +4411,7 @@
                 <a:solidFill>
                   <a:srgbClr val="333333"/>
                 </a:solidFill>
-                <a:latin typeface="WenQuanYi Micro Hei"/>
+                <a:latin typeface="Microsoft YaHei"/>
               </a:rPr>
               <a:t/>
             </a:r>
@@ -4427,7 +4427,7 @@
                 <a:solidFill>
                   <a:srgbClr val="333333"/>
                 </a:solidFill>
-                <a:latin typeface="WenQuanYi Micro Hei"/>
+                <a:latin typeface="Microsoft YaHei"/>
               </a:rPr>
               <a:t>─────────────────────────────</a:t>
             </a:r>
@@ -4443,7 +4443,7 @@
                 <a:solidFill>
                   <a:srgbClr val="333333"/>
                 </a:solidFill>
-                <a:latin typeface="WenQuanYi Micro Hei"/>
+                <a:latin typeface="Microsoft YaHei"/>
               </a:rPr>
               <a:t>月增收合计              +¥70,000</a:t>
             </a:r>
@@ -4459,7 +4459,7 @@
                 <a:solidFill>
                   <a:srgbClr val="333333"/>
                 </a:solidFill>
-                <a:latin typeface="WenQuanYi Micro Hei"/>
+                <a:latin typeface="Microsoft YaHei"/>
               </a:rPr>
               <a:t>减：月度运营成本         -¥6,000</a:t>
             </a:r>
@@ -4475,7 +4475,7 @@
                 <a:solidFill>
                   <a:srgbClr val="333333"/>
                 </a:solidFill>
-                <a:latin typeface="WenQuanYi Micro Hei"/>
+                <a:latin typeface="Microsoft YaHei"/>
               </a:rPr>
               <a:t>─────────────────────────────</a:t>
             </a:r>
@@ -4491,7 +4491,7 @@
                 <a:solidFill>
                   <a:srgbClr val="333333"/>
                 </a:solidFill>
-                <a:latin typeface="WenQuanYi Micro Hei"/>
+                <a:latin typeface="Microsoft YaHei"/>
               </a:rPr>
               <a:t>月净增利润              +¥64,000</a:t>
             </a:r>
@@ -4507,7 +4507,7 @@
                 <a:solidFill>
                   <a:srgbClr val="333333"/>
                 </a:solidFill>
-                <a:latin typeface="WenQuanYi Micro Hei"/>
+                <a:latin typeface="Microsoft YaHei"/>
               </a:rPr>
               <a:t/>
             </a:r>
@@ -4523,7 +4523,7 @@
                 <a:solidFill>
                   <a:srgbClr val="333333"/>
                 </a:solidFill>
-                <a:latin typeface="WenQuanYi Micro Hei"/>
+                <a:latin typeface="Microsoft YaHei"/>
               </a:rPr>
               <a:t>🏆 ROI：月投入¥6,000 → 月增收¥70,000</a:t>
             </a:r>
@@ -4539,7 +4539,7 @@
                 <a:solidFill>
                   <a:srgbClr val="333333"/>
                 </a:solidFill>
-                <a:latin typeface="WenQuanYi Micro Hei"/>
+                <a:latin typeface="Microsoft YaHei"/>
               </a:rPr>
               <a:t>    投入产出比 = 1:11.7</a:t>
             </a:r>
@@ -4555,7 +4555,7 @@
                 <a:solidFill>
                   <a:srgbClr val="333333"/>
                 </a:solidFill>
-                <a:latin typeface="WenQuanYi Micro Hei"/>
+                <a:latin typeface="Microsoft YaHei"/>
               </a:rPr>
               <a:t>    纯增量回本周期 &lt; 1个月</a:t>
             </a:r>
@@ -4660,7 +4660,7 @@
                 <a:solidFill>
                   <a:srgbClr val="FFFFFF"/>
                 </a:solidFill>
-                <a:latin typeface="WenQuanYi Micro Hei"/>
+                <a:latin typeface="Microsoft YaHei"/>
               </a:rPr>
               <a:t>✨ 峰终定律：两个记忆点决定顾客会不会再来</a:t>
             </a:r>
@@ -4695,7 +4695,7 @@
                 <a:solidFill>
                   <a:srgbClr val="BBDEFB"/>
                 </a:solidFill>
-                <a:latin typeface="WenQuanYi Micro Hei"/>
+                <a:latin typeface="Microsoft YaHei"/>
               </a:rPr>
               <a:t>峰值=最爽瞬间 | 终值=离店感觉 | 零成本嵌入现有流程</a:t>
             </a:r>
@@ -4730,7 +4730,7 @@
                 <a:solidFill>
                   <a:srgbClr val="FF6D00"/>
                 </a:solidFill>
-                <a:latin typeface="WenQuanYi Micro Hei"/>
+                <a:latin typeface="Microsoft YaHei"/>
               </a:rPr>
               <a:t>🔥 峰值触点（选2个）</a:t>
             </a:r>
@@ -4769,7 +4769,7 @@
                 <a:solidFill>
                   <a:srgbClr val="333333"/>
                 </a:solidFill>
-                <a:latin typeface="WenQuanYi Micro Hei"/>
+                <a:latin typeface="Microsoft YaHei"/>
               </a:rPr>
               <a:t>① 上菜仪式感：招牌锅底上桌时服务员报菜名+浇油点火</a:t>
             </a:r>
@@ -4785,7 +4785,7 @@
                 <a:solidFill>
                   <a:srgbClr val="333333"/>
                 </a:solidFill>
-                <a:latin typeface="WenQuanYi Micro Hei"/>
+                <a:latin typeface="Microsoft YaHei"/>
               </a:rPr>
               <a:t>   · 成本：¥0（已有服务流程微调）</a:t>
             </a:r>
@@ -4801,7 +4801,7 @@
                 <a:solidFill>
                   <a:srgbClr val="333333"/>
                 </a:solidFill>
-                <a:latin typeface="WenQuanYi Micro Hei"/>
+                <a:latin typeface="Microsoft YaHei"/>
               </a:rPr>
               <a:t>   · 效果：社交平台自发传播，小红书出片率+50%</a:t>
             </a:r>
@@ -4817,7 +4817,7 @@
                 <a:solidFill>
                   <a:srgbClr val="333333"/>
                 </a:solidFill>
-                <a:latin typeface="WenQuanYi Micro Hei"/>
+                <a:latin typeface="Microsoft YaHei"/>
               </a:rPr>
               <a:t/>
             </a:r>
@@ -4833,7 +4833,7 @@
                 <a:solidFill>
                   <a:srgbClr val="333333"/>
                 </a:solidFill>
-                <a:latin typeface="WenQuanYi Micro Hei"/>
+                <a:latin typeface="Microsoft YaHei"/>
               </a:rPr>
               <a:t>② 扫码惊喜弹窗：首次扫码点餐弹出「新客专享·锅底升级券」</a:t>
             </a:r>
@@ -4849,7 +4849,7 @@
                 <a:solidFill>
                   <a:srgbClr val="333333"/>
                 </a:solidFill>
-                <a:latin typeface="WenQuanYi Micro Hei"/>
+                <a:latin typeface="Microsoft YaHei"/>
               </a:rPr>
               <a:t>   · 成本：¥0（系统配置，🔧扫码点餐后台设置）</a:t>
             </a:r>
@@ -4865,7 +4865,7 @@
                 <a:solidFill>
                   <a:srgbClr val="333333"/>
                 </a:solidFill>
-                <a:latin typeface="WenQuanYi Micro Hei"/>
+                <a:latin typeface="Microsoft YaHei"/>
               </a:rPr>
               <a:t>   · 效果：新客好感度拉满，入会率提升至95%+</a:t>
             </a:r>
@@ -4900,7 +4900,7 @@
                 <a:solidFill>
                   <a:srgbClr val="1A73E8"/>
                 </a:solidFill>
-                <a:latin typeface="WenQuanYi Micro Hei"/>
+                <a:latin typeface="Microsoft YaHei"/>
               </a:rPr>
               <a:t>💫 终值触点（选2个）</a:t>
             </a:r>
@@ -4939,7 +4939,7 @@
                 <a:solidFill>
                   <a:srgbClr val="333333"/>
                 </a:solidFill>
-                <a:latin typeface="WenQuanYi Micro Hei"/>
+                <a:latin typeface="Microsoft YaHei"/>
               </a:rPr>
               <a:t>① 结账「本单已省」反馈：POS结账自动显示「您是金卡会员，</a:t>
             </a:r>
@@ -4955,7 +4955,7 @@
                 <a:solidFill>
                   <a:srgbClr val="333333"/>
                 </a:solidFill>
-                <a:latin typeface="WenQuanYi Micro Hei"/>
+                <a:latin typeface="Microsoft YaHei"/>
               </a:rPr>
               <a:t>   本单已为您节省¥XX」→ 强化会员价值感知</a:t>
             </a:r>
@@ -4971,7 +4971,7 @@
                 <a:solidFill>
                   <a:srgbClr val="333333"/>
                 </a:solidFill>
-                <a:latin typeface="WenQuanYi Micro Hei"/>
+                <a:latin typeface="Microsoft YaHei"/>
               </a:rPr>
               <a:t>   · 成本：¥0（🔧会员系统自动计算显示）</a:t>
             </a:r>
@@ -4987,7 +4987,7 @@
                 <a:solidFill>
                   <a:srgbClr val="333333"/>
                 </a:solidFill>
-                <a:latin typeface="WenQuanYi Micro Hei"/>
+                <a:latin typeface="Microsoft YaHei"/>
               </a:rPr>
               <a:t/>
             </a:r>
@@ -5003,7 +5003,7 @@
                 <a:solidFill>
                   <a:srgbClr val="333333"/>
                 </a:solidFill>
-                <a:latin typeface="WenQuanYi Micro Hei"/>
+                <a:latin typeface="Microsoft YaHei"/>
               </a:rPr>
               <a:t>② 离店关怀+储值未用提醒：离店后2小时推送</a:t>
             </a:r>
@@ -5019,7 +5019,7 @@
                 <a:solidFill>
                   <a:srgbClr val="333333"/>
                 </a:solidFill>
-                <a:latin typeface="WenQuanYi Micro Hei"/>
+                <a:latin typeface="Microsoft YaHei"/>
               </a:rPr>
               <a:t>   「感谢光临，您的储值余额还剩¥XXX，期待下次」</a:t>
             </a:r>
@@ -5035,7 +5035,7 @@
                 <a:solidFill>
                   <a:srgbClr val="333333"/>
                 </a:solidFill>
-                <a:latin typeface="WenQuanYi Micro Hei"/>
+                <a:latin typeface="Microsoft YaHei"/>
               </a:rPr>
               <a:t>   · 成本：¥0（🔧会员触达自动设置）</a:t>
             </a:r>
@@ -5051,7 +5051,7 @@
                 <a:solidFill>
                   <a:srgbClr val="333333"/>
                 </a:solidFill>
-                <a:latin typeface="WenQuanYi Micro Hei"/>
+                <a:latin typeface="Microsoft YaHei"/>
               </a:rPr>
               <a:t>   · 效果：让顾客带着「余额未用」的念想离开→复购动力</a:t>
             </a:r>
@@ -5086,7 +5086,7 @@
                 <a:solidFill>
                   <a:srgbClr val="666666"/>
                 </a:solidFill>
-                <a:latin typeface="WenQuanYi Micro Hei"/>
+                <a:latin typeface="Microsoft YaHei"/>
               </a:rPr>
               <a:t>💡 原则：每个触点成本&lt;客单价3%（即&lt;¥3.3），且嵌入已有流程，不增加额外操作</a:t>
             </a:r>
@@ -5191,7 +5191,7 @@
                 <a:solidFill>
                   <a:srgbClr val="FFFFFF"/>
                 </a:solidFill>
-                <a:latin typeface="WenQuanYi Micro Hei"/>
+                <a:latin typeface="Microsoft YaHei"/>
               </a:rPr>
               <a:t>蜀香坊火锅 × 美团收银</a:t>
             </a:r>
@@ -5226,7 +5226,7 @@
                 <a:solidFill>
                   <a:srgbClr val="90CAF9"/>
                 </a:solidFill>
-                <a:latin typeface="WenQuanYi Micro Hei"/>
+                <a:latin typeface="Microsoft YaHei"/>
               </a:rPr>
               <a:t>储值锁客 | 工作日引流 | 公域新客 | 会员运营 | 数据驱动</a:t>
             </a:r>
@@ -5261,7 +5261,7 @@
                 <a:solidFill>
                   <a:srgbClr val="BBDEFB"/>
                 </a:solidFill>
-                <a:latin typeface="WenQuanYi Micro Hei"/>
+                <a:latin typeface="Microsoft YaHei"/>
               </a:rPr>
               <a:t>让每一桌客人都成为「下一桌」的起点</a:t>
             </a:r>
@@ -5296,7 +5296,7 @@
                 <a:solidFill>
                   <a:srgbClr val="789EC9"/>
                 </a:solidFill>
-                <a:latin typeface="WenQuanYi Micro Hei"/>
+                <a:latin typeface="Microsoft YaHei"/>
               </a:rPr>
               <a:t>美团餐饮SaaS · 杭州萧山团队 · 2026年5月</a:t>
             </a:r>
@@ -5401,7 +5401,7 @@
                 <a:solidFill>
                   <a:srgbClr val="FFFFFF"/>
                 </a:solidFill>
-                <a:latin typeface="WenQuanYi Micro Hei"/>
+                <a:latin typeface="Microsoft YaHei"/>
               </a:rPr>
               <a:t>📋 执行手册①：员工话术卡</a:t>
             </a:r>
@@ -5436,7 +5436,7 @@
                 <a:solidFill>
                   <a:srgbClr val="FFE0B2"/>
                 </a:solidFill>
-                <a:latin typeface="WenQuanYi Micro Hei"/>
+                <a:latin typeface="Microsoft YaHei"/>
               </a:rPr>
               <a:t>每个场景一张卡 · 员工看一眼就会说</a:t>
             </a:r>
@@ -5475,7 +5475,7 @@
                 <a:solidFill>
                   <a:srgbClr val="333333"/>
                 </a:solidFill>
-                <a:latin typeface="WenQuanYi Micro Hei"/>
+                <a:latin typeface="Microsoft YaHei"/>
               </a:rPr>
               <a:t>┌──────────────────────────────────────────────────────────────────┐</a:t>
             </a:r>
@@ -5491,7 +5491,7 @@
                 <a:solidFill>
                   <a:srgbClr val="333333"/>
                 </a:solidFill>
-                <a:latin typeface="WenQuanYi Micro Hei"/>
+                <a:latin typeface="Microsoft YaHei"/>
               </a:rPr>
               <a:t>│ 🎯 场景：结账推储值                                              │</a:t>
             </a:r>
@@ -5507,7 +5507,7 @@
                 <a:solidFill>
                   <a:srgbClr val="333333"/>
                 </a:solidFill>
-                <a:latin typeface="WenQuanYi Micro Hei"/>
+                <a:latin typeface="Microsoft YaHei"/>
               </a:rPr>
               <a:t>│ 👤 岗位：收银员    ⏰ 触发：客人买单时（POS自动弹窗提示）         │</a:t>
             </a:r>
@@ -5523,7 +5523,7 @@
                 <a:solidFill>
                   <a:srgbClr val="333333"/>
                 </a:solidFill>
-                <a:latin typeface="WenQuanYi Micro Hei"/>
+                <a:latin typeface="Microsoft YaHei"/>
               </a:rPr>
               <a:t>│──────────────────────────────────────────────────────────────────│</a:t>
             </a:r>
@@ -5539,7 +5539,7 @@
                 <a:solidFill>
                   <a:srgbClr val="333333"/>
                 </a:solidFill>
-                <a:latin typeface="WenQuanYi Micro Hei"/>
+                <a:latin typeface="Microsoft YaHei"/>
               </a:rPr>
               <a:t>│ 💬 标准话术：                                                    │</a:t>
             </a:r>
@@ -5555,7 +5555,7 @@
                 <a:solidFill>
                   <a:srgbClr val="333333"/>
                 </a:solidFill>
-                <a:latin typeface="WenQuanYi Micro Hei"/>
+                <a:latin typeface="Microsoft YaHei"/>
               </a:rPr>
               <a:t>│ 「您今天消费¥420，充1000送130到账1130，这单直接抵扣省¥55，      │</a:t>
             </a:r>
@@ -5571,7 +5571,7 @@
                 <a:solidFill>
                   <a:srgbClr val="333333"/>
                 </a:solidFill>
-                <a:latin typeface="WenQuanYi Micro Hei"/>
+                <a:latin typeface="Microsoft YaHei"/>
               </a:rPr>
               <a:t>│   剩余¥710够您下次再来2次，相当于打了8.8折～」                   │</a:t>
             </a:r>
@@ -5587,7 +5587,7 @@
                 <a:solidFill>
                   <a:srgbClr val="333333"/>
                 </a:solidFill>
-                <a:latin typeface="WenQuanYi Micro Hei"/>
+                <a:latin typeface="Microsoft YaHei"/>
               </a:rPr>
               <a:t>│ 🔄 犹豫时：「充500也可以，送50到账550，这单省¥25，下次来还有」   │</a:t>
             </a:r>
@@ -5603,7 +5603,7 @@
                 <a:solidFill>
                   <a:srgbClr val="333333"/>
                 </a:solidFill>
-                <a:latin typeface="WenQuanYi Micro Hei"/>
+                <a:latin typeface="Microsoft YaHei"/>
               </a:rPr>
               <a:t>│ ❌ 拒绝时：「没关系，活动一直在，下次来随时可以充～慢走」        │</a:t>
             </a:r>
@@ -5619,7 +5619,7 @@
                 <a:solidFill>
                   <a:srgbClr val="333333"/>
                 </a:solidFill>
-                <a:latin typeface="WenQuanYi Micro Hei"/>
+                <a:latin typeface="Microsoft YaHei"/>
               </a:rPr>
               <a:t>│ ✅ 成功标志：客人完成储值，POS显示余额                           │</a:t>
             </a:r>
@@ -5635,7 +5635,7 @@
                 <a:solidFill>
                   <a:srgbClr val="333333"/>
                 </a:solidFill>
-                <a:latin typeface="WenQuanYi Micro Hei"/>
+                <a:latin typeface="Microsoft YaHei"/>
               </a:rPr>
               <a:t>└──────────────────────────────────────────────────────────────────┘</a:t>
             </a:r>
@@ -5651,7 +5651,7 @@
                 <a:solidFill>
                   <a:srgbClr val="333333"/>
                 </a:solidFill>
-                <a:latin typeface="WenQuanYi Micro Hei"/>
+                <a:latin typeface="Microsoft YaHei"/>
               </a:rPr>
               <a:t/>
             </a:r>
@@ -5667,7 +5667,7 @@
                 <a:solidFill>
                   <a:srgbClr val="333333"/>
                 </a:solidFill>
-                <a:latin typeface="WenQuanYi Micro Hei"/>
+                <a:latin typeface="Microsoft YaHei"/>
               </a:rPr>
               <a:t>┌──────────────────────────────────────────────────────────────────┐</a:t>
             </a:r>
@@ -5683,7 +5683,7 @@
                 <a:solidFill>
                   <a:srgbClr val="333333"/>
                 </a:solidFill>
-                <a:latin typeface="WenQuanYi Micro Hei"/>
+                <a:latin typeface="Microsoft YaHei"/>
               </a:rPr>
               <a:t>│ 🎯 场景：工作日套餐推荐                                          │</a:t>
             </a:r>
@@ -5699,7 +5699,7 @@
                 <a:solidFill>
                   <a:srgbClr val="333333"/>
                 </a:solidFill>
-                <a:latin typeface="WenQuanYi Micro Hei"/>
+                <a:latin typeface="Microsoft YaHei"/>
               </a:rPr>
               <a:t>│ 👤 岗位：服务员    ⏰ 触发：工作日客人落座看菜单时               │</a:t>
             </a:r>
@@ -5715,7 +5715,7 @@
                 <a:solidFill>
                   <a:srgbClr val="333333"/>
                 </a:solidFill>
-                <a:latin typeface="WenQuanYi Micro Hei"/>
+                <a:latin typeface="Microsoft YaHei"/>
               </a:rPr>
               <a:t>│──────────────────────────────────────────────────────────────────│</a:t>
             </a:r>
@@ -5731,7 +5731,7 @@
                 <a:solidFill>
                   <a:srgbClr val="333333"/>
                 </a:solidFill>
-                <a:latin typeface="WenQuanYi Micro Hei"/>
+                <a:latin typeface="Microsoft YaHei"/>
               </a:rPr>
               <a:t>│ 💬 标准话术：                                                    │</a:t>
             </a:r>
@@ -5747,7 +5747,7 @@
                 <a:solidFill>
                   <a:srgbClr val="333333"/>
                 </a:solidFill>
-                <a:latin typeface="WenQuanYi Micro Hei"/>
+                <a:latin typeface="Microsoft YaHei"/>
               </a:rPr>
               <a:t>│ 「今天工作日我们有专属套餐，3位的话推荐¥299这个，锅底+5荤3素+   │</a:t>
             </a:r>
@@ -5763,7 +5763,7 @@
                 <a:solidFill>
                   <a:srgbClr val="333333"/>
                 </a:solidFill>
-                <a:latin typeface="WenQuanYi Micro Hei"/>
+                <a:latin typeface="Microsoft YaHei"/>
               </a:rPr>
               <a:t>│   饮品都包了，比单点省¥81，很多附近上班的客人都点这个～」        │</a:t>
             </a:r>
@@ -5779,7 +5779,7 @@
                 <a:solidFill>
                   <a:srgbClr val="333333"/>
                 </a:solidFill>
-                <a:latin typeface="WenQuanYi Micro Hei"/>
+                <a:latin typeface="Microsoft YaHei"/>
               </a:rPr>
               <a:t>│ 🔄 犹豫时：「您先看菜单也行，套餐随时可以加，不着急」           │</a:t>
             </a:r>
@@ -5795,7 +5795,7 @@
                 <a:solidFill>
                   <a:srgbClr val="333333"/>
                 </a:solidFill>
-                <a:latin typeface="WenQuanYi Micro Hei"/>
+                <a:latin typeface="Microsoft YaHei"/>
               </a:rPr>
               <a:t>└──────────────────────────────────────────────────────────────────┘</a:t>
             </a:r>
@@ -5811,7 +5811,7 @@
                 <a:solidFill>
                   <a:srgbClr val="333333"/>
                 </a:solidFill>
-                <a:latin typeface="WenQuanYi Micro Hei"/>
+                <a:latin typeface="Microsoft YaHei"/>
               </a:rPr>
               <a:t/>
             </a:r>
@@ -5827,7 +5827,7 @@
                 <a:solidFill>
                   <a:srgbClr val="333333"/>
                 </a:solidFill>
-                <a:latin typeface="WenQuanYi Micro Hei"/>
+                <a:latin typeface="Microsoft YaHei"/>
               </a:rPr>
               <a:t>┌──────────────────────────────────────────────────────────────────┐</a:t>
             </a:r>
@@ -5843,7 +5843,7 @@
                 <a:solidFill>
                   <a:srgbClr val="333333"/>
                 </a:solidFill>
-                <a:latin typeface="WenQuanYi Micro Hei"/>
+                <a:latin typeface="Microsoft YaHei"/>
               </a:rPr>
               <a:t>│ 🎯 场景：好评引导                                                │</a:t>
             </a:r>
@@ -5859,7 +5859,7 @@
                 <a:solidFill>
                   <a:srgbClr val="333333"/>
                 </a:solidFill>
-                <a:latin typeface="WenQuanYi Micro Hei"/>
+                <a:latin typeface="Microsoft YaHei"/>
               </a:rPr>
               <a:t>│ 👤 岗位：服务员    ⏰ 触发：客人表示吃得满意/结账后              │</a:t>
             </a:r>
@@ -5875,7 +5875,7 @@
                 <a:solidFill>
                   <a:srgbClr val="333333"/>
                 </a:solidFill>
-                <a:latin typeface="WenQuanYi Micro Hei"/>
+                <a:latin typeface="Microsoft YaHei"/>
               </a:rPr>
               <a:t>│──────────────────────────────────────────────────────────────────│</a:t>
             </a:r>
@@ -5891,7 +5891,7 @@
                 <a:solidFill>
                   <a:srgbClr val="333333"/>
                 </a:solidFill>
-                <a:latin typeface="WenQuanYi Micro Hei"/>
+                <a:latin typeface="Microsoft YaHei"/>
               </a:rPr>
               <a:t>│ 💬 话术：「谢谢认可！如果方便在点评上写两句，对我们帮助很大～    │</a:t>
             </a:r>
@@ -5907,7 +5907,7 @@
                 <a:solidFill>
                   <a:srgbClr val="333333"/>
                 </a:solidFill>
-                <a:latin typeface="WenQuanYi Micro Hei"/>
+                <a:latin typeface="Microsoft YaHei"/>
               </a:rPr>
               <a:t>│   您结账后手机会自动弹出评价页面，很方便的」                     │</a:t>
             </a:r>
@@ -5923,7 +5923,7 @@
                 <a:solidFill>
                   <a:srgbClr val="333333"/>
                 </a:solidFill>
-                <a:latin typeface="WenQuanYi Micro Hei"/>
+                <a:latin typeface="Microsoft YaHei"/>
               </a:rPr>
               <a:t>└──────────────────────────────────────────────────────────────────┘</a:t>
             </a:r>
@@ -6028,7 +6028,7 @@
                 <a:solidFill>
                   <a:srgbClr val="FFFFFF"/>
                 </a:solidFill>
-                <a:latin typeface="WenQuanYi Micro Hei"/>
+                <a:latin typeface="Microsoft YaHei"/>
               </a:rPr>
               <a:t>📋 执行手册②：关键活动SOP</a:t>
             </a:r>
@@ -6063,7 +6063,7 @@
                 <a:solidFill>
                   <a:srgbClr val="FFE0B2"/>
                 </a:solidFill>
-                <a:latin typeface="WenQuanYi Micro Hei"/>
+                <a:latin typeface="Microsoft YaHei"/>
               </a:rPr>
               <a:t>从方案到落地的执行步骤</a:t>
             </a:r>
@@ -6102,7 +6102,7 @@
                 <a:solidFill>
                   <a:srgbClr val="333333"/>
                 </a:solidFill>
-                <a:latin typeface="WenQuanYi Micro Hei"/>
+                <a:latin typeface="Microsoft YaHei"/>
               </a:rPr>
               <a:t>━━━ SOP-1：储值活动上线 ━━━</a:t>
             </a:r>
@@ -6118,7 +6118,7 @@
                 <a:solidFill>
                   <a:srgbClr val="333333"/>
                 </a:solidFill>
-                <a:latin typeface="WenQuanYi Micro Hei"/>
+                <a:latin typeface="Microsoft YaHei"/>
               </a:rPr>
               <a:t>D-3: 🔧美团收银后台→会员营销→储值规则→配置4档(500/1000/2000/5000)</a:t>
             </a:r>
@@ -6134,7 +6134,7 @@
                 <a:solidFill>
                   <a:srgbClr val="333333"/>
                 </a:solidFill>
-                <a:latin typeface="WenQuanYi Micro Hei"/>
+                <a:latin typeface="Microsoft YaHei"/>
               </a:rPr>
               <a:t>D-2: 🔧设置POS结账弹窗→选择储值推荐样式→测试弹窗展示</a:t>
             </a:r>
@@ -6150,7 +6150,7 @@
                 <a:solidFill>
                   <a:srgbClr val="333333"/>
                 </a:solidFill>
-                <a:latin typeface="WenQuanYi Micro Hei"/>
+                <a:latin typeface="Microsoft YaHei"/>
               </a:rPr>
               <a:t>D-1: 打印桌贴物料(A5)「充1000送130」+收银台立牌；员工培训话术(15分钟站会)</a:t>
             </a:r>
@@ -6166,7 +6166,7 @@
                 <a:solidFill>
                   <a:srgbClr val="333333"/>
                 </a:solidFill>
-                <a:latin typeface="WenQuanYi Micro Hei"/>
+                <a:latin typeface="Microsoft YaHei"/>
               </a:rPr>
               <a:t>D0:  正式上线，店长监督前5桌话术执行，发现问题当场纠正</a:t>
             </a:r>
@@ -6182,7 +6182,7 @@
                 <a:solidFill>
                   <a:srgbClr val="333333"/>
                 </a:solidFill>
-                <a:latin typeface="WenQuanYi Micro Hei"/>
+                <a:latin typeface="Microsoft YaHei"/>
               </a:rPr>
               <a:t>D+7: 后台查看首周数据：储值笔数/金额/档位分布，调整话术重点</a:t>
             </a:r>
@@ -6198,7 +6198,7 @@
                 <a:solidFill>
                   <a:srgbClr val="333333"/>
                 </a:solidFill>
-                <a:latin typeface="WenQuanYi Micro Hei"/>
+                <a:latin typeface="Microsoft YaHei"/>
               </a:rPr>
               <a:t/>
             </a:r>
@@ -6214,7 +6214,7 @@
                 <a:solidFill>
                   <a:srgbClr val="333333"/>
                 </a:solidFill>
-                <a:latin typeface="WenQuanYi Micro Hei"/>
+                <a:latin typeface="Microsoft YaHei"/>
               </a:rPr>
               <a:t>━━━ SOP-2：「周三火锅日」上线 ━━━</a:t>
             </a:r>
@@ -6230,7 +6230,7 @@
                 <a:solidFill>
                   <a:srgbClr val="333333"/>
                 </a:solidFill>
-                <a:latin typeface="WenQuanYi Micro Hei"/>
+                <a:latin typeface="Microsoft YaHei"/>
               </a:rPr>
               <a:t>D-5: 🔧会员后台→创建定时活动→周三锅底8折→适用对象：储值会员</a:t>
             </a:r>
@@ -6246,7 +6246,7 @@
                 <a:solidFill>
                   <a:srgbClr val="333333"/>
                 </a:solidFill>
-                <a:latin typeface="WenQuanYi Micro Hei"/>
+                <a:latin typeface="Microsoft YaHei"/>
               </a:rPr>
               <a:t>D-3: 🔧自动触达→设置每周二15:00推送消息「明天周三火锅日，锅底8折等你」</a:t>
             </a:r>
@@ -6262,7 +6262,7 @@
                 <a:solidFill>
                   <a:srgbClr val="333333"/>
                 </a:solidFill>
-                <a:latin typeface="WenQuanYi Micro Hei"/>
+                <a:latin typeface="Microsoft YaHei"/>
               </a:rPr>
               <a:t>D-1: 朋友圈/大象群发布预告(店长个人号)</a:t>
             </a:r>
@@ -6278,7 +6278,7 @@
                 <a:solidFill>
                   <a:srgbClr val="333333"/>
                 </a:solidFill>
-                <a:latin typeface="WenQuanYi Micro Hei"/>
+                <a:latin typeface="Microsoft YaHei"/>
               </a:rPr>
               <a:t>D0(周三): 门口放「今日火锅日」立牌；收银台弹窗提醒非储值客「充值即享」</a:t>
             </a:r>
@@ -6294,7 +6294,7 @@
                 <a:solidFill>
                   <a:srgbClr val="333333"/>
                 </a:solidFill>
-                <a:latin typeface="WenQuanYi Micro Hei"/>
+                <a:latin typeface="Microsoft YaHei"/>
               </a:rPr>
               <a:t>每周四: 对比周三 vs 其他工作日数据，评估效果</a:t>
             </a:r>
@@ -6310,7 +6310,7 @@
                 <a:solidFill>
                   <a:srgbClr val="333333"/>
                 </a:solidFill>
-                <a:latin typeface="WenQuanYi Micro Hei"/>
+                <a:latin typeface="Microsoft YaHei"/>
               </a:rPr>
               <a:t/>
             </a:r>
@@ -6326,7 +6326,7 @@
                 <a:solidFill>
                   <a:srgbClr val="333333"/>
                 </a:solidFill>
-                <a:latin typeface="WenQuanYi Micro Hei"/>
+                <a:latin typeface="Microsoft YaHei"/>
               </a:rPr>
               <a:t>━━━ SOP-3：大众点评团购套餐上线 ━━━</a:t>
             </a:r>
@@ -6342,7 +6342,7 @@
                 <a:solidFill>
                   <a:srgbClr val="333333"/>
                 </a:solidFill>
-                <a:latin typeface="WenQuanYi Micro Hei"/>
+                <a:latin typeface="Microsoft YaHei"/>
               </a:rPr>
               <a:t>D-3: 准备套餐菜品组合+拍摄图片(手机即可，锅底+食材+全景)</a:t>
             </a:r>
@@ -6358,7 +6358,7 @@
                 <a:solidFill>
                   <a:srgbClr val="333333"/>
                 </a:solidFill>
-                <a:latin typeface="WenQuanYi Micro Hei"/>
+                <a:latin typeface="Microsoft YaHei"/>
               </a:rPr>
               <a:t>D-2: 🔧美团商家后台→团购管理→创建套餐→标题含「工作日」「商务聚餐」关键词</a:t>
             </a:r>
@@ -6374,7 +6374,7 @@
                 <a:solidFill>
                   <a:srgbClr val="333333"/>
                 </a:solidFill>
-                <a:latin typeface="WenQuanYi Micro Hei"/>
+                <a:latin typeface="Microsoft YaHei"/>
               </a:rPr>
               <a:t>D-1: 设置库存(每日限5份，制造稀缺感)；定价¥299/¥599确认上线</a:t>
             </a:r>
@@ -6390,7 +6390,7 @@
                 <a:solidFill>
                   <a:srgbClr val="333333"/>
                 </a:solidFill>
-                <a:latin typeface="WenQuanYi Micro Hei"/>
+                <a:latin typeface="Microsoft YaHei"/>
               </a:rPr>
               <a:t>D0:  团购上线，监控首日核销情况</a:t>
             </a:r>
@@ -6406,7 +6406,7 @@
                 <a:solidFill>
                   <a:srgbClr val="333333"/>
                 </a:solidFill>
-                <a:latin typeface="WenQuanYi Micro Hei"/>
+                <a:latin typeface="Microsoft YaHei"/>
               </a:rPr>
               <a:t>W+2: 根据核销数据调整库存限制/定价</a:t>
             </a:r>
@@ -6511,7 +6511,7 @@
                 <a:solidFill>
                   <a:srgbClr val="FFFFFF"/>
                 </a:solidFill>
-                <a:latin typeface="WenQuanYi Micro Hei"/>
+                <a:latin typeface="Microsoft YaHei"/>
               </a:rPr>
               <a:t>📋 执行手册③：每日检查清单</a:t>
             </a:r>
@@ -6546,7 +6546,7 @@
                 <a:solidFill>
                   <a:srgbClr val="FFE0B2"/>
                 </a:solidFill>
-                <a:latin typeface="WenQuanYi Micro Hei"/>
+                <a:latin typeface="Microsoft YaHei"/>
               </a:rPr>
               <a:t>店长每天5分钟过一遍 · OKR拆解到日</a:t>
             </a:r>
@@ -6585,7 +6585,7 @@
                 <a:solidFill>
                   <a:srgbClr val="333333"/>
                 </a:solidFill>
-                <a:latin typeface="WenQuanYi Micro Hei"/>
+                <a:latin typeface="Microsoft YaHei"/>
               </a:rPr>
               <a:t>━━━━━━━━━━━━━━ 每日店长检查清单 ━━━━━━━━━━━━━━</a:t>
             </a:r>
@@ -6601,7 +6601,7 @@
                 <a:solidFill>
                   <a:srgbClr val="333333"/>
                 </a:solidFill>
-                <a:latin typeface="WenQuanYi Micro Hei"/>
+                <a:latin typeface="Microsoft YaHei"/>
               </a:rPr>
               <a:t/>
             </a:r>
@@ -6617,7 +6617,7 @@
                 <a:solidFill>
                   <a:srgbClr val="333333"/>
                 </a:solidFill>
-                <a:latin typeface="WenQuanYi Micro Hei"/>
+                <a:latin typeface="Microsoft YaHei"/>
               </a:rPr>
               <a:t>📊 数据检查（每日18:00看一次）</a:t>
             </a:r>
@@ -6633,7 +6633,7 @@
                 <a:solidFill>
                   <a:srgbClr val="333333"/>
                 </a:solidFill>
-                <a:latin typeface="WenQuanYi Micro Hei"/>
+                <a:latin typeface="Microsoft YaHei"/>
               </a:rPr>
               <a:t>  □ 今日营业额：目标¥17,333（月目标¥520,000÷30）  实际：_______</a:t>
             </a:r>
@@ -6649,7 +6649,7 @@
                 <a:solidFill>
                   <a:srgbClr val="333333"/>
                 </a:solidFill>
-                <a:latin typeface="WenQuanYi Micro Hei"/>
+                <a:latin typeface="Microsoft YaHei"/>
               </a:rPr>
               <a:t>  □ 今日储值笔数：目标3笔/天（月目标80笔÷26营业日）  实际：_______</a:t>
             </a:r>
@@ -6665,7 +6665,7 @@
                 <a:solidFill>
                   <a:srgbClr val="333333"/>
                 </a:solidFill>
-                <a:latin typeface="WenQuanYi Micro Hei"/>
+                <a:latin typeface="Microsoft YaHei"/>
               </a:rPr>
               <a:t>  □ 今日新增会员：目标25人/天（月目标750人÷30）  实际：_______</a:t>
             </a:r>
@@ -6681,7 +6681,7 @@
                 <a:solidFill>
                   <a:srgbClr val="333333"/>
                 </a:solidFill>
-                <a:latin typeface="WenQuanYi Micro Hei"/>
+                <a:latin typeface="Microsoft YaHei"/>
               </a:rPr>
               <a:t>  □ 今日工作日/周末翻台率：目标工作日1.3 / 周末2.8  实际：_______</a:t>
             </a:r>
@@ -6697,7 +6697,7 @@
                 <a:solidFill>
                   <a:srgbClr val="333333"/>
                 </a:solidFill>
-                <a:latin typeface="WenQuanYi Micro Hei"/>
+                <a:latin typeface="Microsoft YaHei"/>
               </a:rPr>
               <a:t/>
             </a:r>
@@ -6713,7 +6713,7 @@
                 <a:solidFill>
                   <a:srgbClr val="333333"/>
                 </a:solidFill>
-                <a:latin typeface="WenQuanYi Micro Hei"/>
+                <a:latin typeface="Microsoft YaHei"/>
               </a:rPr>
               <a:t>🗣️ 话术执行检查（晚高峰巡台时）</a:t>
             </a:r>
@@ -6729,7 +6729,7 @@
                 <a:solidFill>
                   <a:srgbClr val="333333"/>
                 </a:solidFill>
-                <a:latin typeface="WenQuanYi Micro Hei"/>
+                <a:latin typeface="Microsoft YaHei"/>
               </a:rPr>
               <a:t>  □ 储值话术开口率 ≥ 80%（抽查5桌，至少4桌有推荐）</a:t>
             </a:r>
@@ -6745,7 +6745,7 @@
                 <a:solidFill>
                   <a:srgbClr val="333333"/>
                 </a:solidFill>
-                <a:latin typeface="WenQuanYi Micro Hei"/>
+                <a:latin typeface="Microsoft YaHei"/>
               </a:rPr>
               <a:t>  □ 工作日套餐推荐率 100%（周一至周五每桌必提）</a:t>
             </a:r>
@@ -6761,7 +6761,7 @@
                 <a:solidFill>
                   <a:srgbClr val="333333"/>
                 </a:solidFill>
-                <a:latin typeface="WenQuanYi Micro Hei"/>
+                <a:latin typeface="Microsoft YaHei"/>
               </a:rPr>
               <a:t>  □ 好评引导执行（满意客人离店前提醒）</a:t>
             </a:r>
@@ -6777,7 +6777,7 @@
                 <a:solidFill>
                   <a:srgbClr val="333333"/>
                 </a:solidFill>
-                <a:latin typeface="WenQuanYi Micro Hei"/>
+                <a:latin typeface="Microsoft YaHei"/>
               </a:rPr>
               <a:t/>
             </a:r>
@@ -6793,7 +6793,7 @@
                 <a:solidFill>
                   <a:srgbClr val="333333"/>
                 </a:solidFill>
-                <a:latin typeface="WenQuanYi Micro Hei"/>
+                <a:latin typeface="Microsoft YaHei"/>
               </a:rPr>
               <a:t>📱 系统检查（每日开店前）</a:t>
             </a:r>
@@ -6809,7 +6809,7 @@
                 <a:solidFill>
                   <a:srgbClr val="333333"/>
                 </a:solidFill>
-                <a:latin typeface="WenQuanYi Micro Hei"/>
+                <a:latin typeface="Microsoft YaHei"/>
               </a:rPr>
               <a:t>  □ POS储值弹窗正常弹出（自己试一笔）</a:t>
             </a:r>
@@ -6825,7 +6825,7 @@
                 <a:solidFill>
                   <a:srgbClr val="333333"/>
                 </a:solidFill>
-                <a:latin typeface="WenQuanYi Micro Hei"/>
+                <a:latin typeface="Microsoft YaHei"/>
               </a:rPr>
               <a:t>  □ 扫码点餐入会流程正常</a:t>
             </a:r>
@@ -6841,7 +6841,7 @@
                 <a:solidFill>
                   <a:srgbClr val="333333"/>
                 </a:solidFill>
-                <a:latin typeface="WenQuanYi Micro Hei"/>
+                <a:latin typeface="Microsoft YaHei"/>
               </a:rPr>
               <a:t>  □ 大众点评团购套餐库存未售罄（工作日限5份）</a:t>
             </a:r>
@@ -6857,7 +6857,7 @@
                 <a:solidFill>
                   <a:srgbClr val="333333"/>
                 </a:solidFill>
-                <a:latin typeface="WenQuanYi Micro Hei"/>
+                <a:latin typeface="Microsoft YaHei"/>
               </a:rPr>
               <a:t/>
             </a:r>
@@ -6873,7 +6873,7 @@
                 <a:solidFill>
                   <a:srgbClr val="333333"/>
                 </a:solidFill>
-                <a:latin typeface="WenQuanYi Micro Hei"/>
+                <a:latin typeface="Microsoft YaHei"/>
               </a:rPr>
               <a:t>📅 周度对标</a:t>
             </a:r>
@@ -6889,7 +6889,7 @@
                 <a:solidFill>
                   <a:srgbClr val="333333"/>
                 </a:solidFill>
-                <a:latin typeface="WenQuanYi Micro Hei"/>
+                <a:latin typeface="Microsoft YaHei"/>
               </a:rPr>
               <a:t>  □ 周三火锅日 vs 其他工作日客流对比（周四看数据）</a:t>
             </a:r>
@@ -6905,7 +6905,7 @@
                 <a:solidFill>
                   <a:srgbClr val="333333"/>
                 </a:solidFill>
-                <a:latin typeface="WenQuanYi Micro Hei"/>
+                <a:latin typeface="Microsoft YaHei"/>
               </a:rPr>
               <a:t>  □ 本周储值总笔数 vs 上周（是否在增长通道）</a:t>
             </a:r>
@@ -6921,7 +6921,7 @@
                 <a:solidFill>
                   <a:srgbClr val="333333"/>
                 </a:solidFill>
-                <a:latin typeface="WenQuanYi Micro Hei"/>
+                <a:latin typeface="Microsoft YaHei"/>
               </a:rPr>
               <a:t>  □ 本周新增点评好评数 ≥ 7条</a:t>
             </a:r>
@@ -6937,7 +6937,7 @@
                 <a:solidFill>
                   <a:srgbClr val="333333"/>
                 </a:solidFill>
-                <a:latin typeface="WenQuanYi Micro Hei"/>
+                <a:latin typeface="Microsoft YaHei"/>
               </a:rPr>
               <a:t/>
             </a:r>
@@ -6953,7 +6953,7 @@
                 <a:solidFill>
                   <a:srgbClr val="333333"/>
                 </a:solidFill>
-                <a:latin typeface="WenQuanYi Micro Hei"/>
+                <a:latin typeface="Microsoft YaHei"/>
               </a:rPr>
               <a:t>🚨 异常响应</a:t>
             </a:r>
@@ -6969,7 +6969,7 @@
                 <a:solidFill>
                   <a:srgbClr val="333333"/>
                 </a:solidFill>
-                <a:latin typeface="WenQuanYi Micro Hei"/>
+                <a:latin typeface="Microsoft YaHei"/>
               </a:rPr>
               <a:t>  □ 连续2天储值&lt;2笔 → 检查话术/弹窗/立牌是否到位</a:t>
             </a:r>
@@ -6985,7 +6985,7 @@
                 <a:solidFill>
                   <a:srgbClr val="333333"/>
                 </a:solidFill>
-                <a:latin typeface="WenQuanYi Micro Hei"/>
+                <a:latin typeface="Microsoft YaHei"/>
               </a:rPr>
               <a:t>  □ 收到差评 → 2小时内联系客人+后台回复</a:t>
             </a:r>
@@ -7001,7 +7001,7 @@
                 <a:solidFill>
                   <a:srgbClr val="333333"/>
                 </a:solidFill>
-                <a:latin typeface="WenQuanYi Micro Hei"/>
+                <a:latin typeface="Microsoft YaHei"/>
               </a:rPr>
               <a:t>  □ 工作日翻台&lt;0.7 → 启动备用方案(朋友圈限时折扣)</a:t>
             </a:r>
@@ -7106,7 +7106,7 @@
                 <a:solidFill>
                   <a:srgbClr val="FFFFFF"/>
                 </a:solidFill>
-                <a:latin typeface="WenQuanYi Micro Hei"/>
+                <a:latin typeface="Microsoft YaHei"/>
               </a:rPr>
               <a:t>📊 数据基石</a:t>
             </a:r>
@@ -7141,7 +7141,7 @@
                 <a:solidFill>
                   <a:srgbClr val="BBDEFB"/>
                 </a:solidFill>
-                <a:latin typeface="WenQuanYi Micro Hei"/>
+                <a:latin typeface="Microsoft YaHei"/>
               </a:rPr>
               <a:t>经营数据交叉验证 · 方案建在真实地基上</a:t>
             </a:r>
@@ -7180,7 +7180,7 @@
                 <a:solidFill>
                   <a:srgbClr val="333333"/>
                 </a:solidFill>
-                <a:latin typeface="WenQuanYi Micro Hei"/>
+                <a:latin typeface="Microsoft YaHei"/>
               </a:rPr>
               <a:t>🏪 门店：蜀香坊火锅 | 萧山区市心路299号银隆百货3楼 | 260㎡</a:t>
             </a:r>
@@ -7196,7 +7196,7 @@
                 <a:solidFill>
                   <a:srgbClr val="333333"/>
                 </a:solidFill>
-                <a:latin typeface="WenQuanYi Micro Hei"/>
+                <a:latin typeface="Microsoft YaHei"/>
               </a:rPr>
               <a:t>💰 月流水：¥450,000 ÷ 30天 = 日均¥15,000</a:t>
             </a:r>
@@ -7212,7 +7212,7 @@
                 <a:solidFill>
                   <a:srgbClr val="333333"/>
                 </a:solidFill>
-                <a:latin typeface="WenQuanYi Micro Hei"/>
+                <a:latin typeface="Microsoft YaHei"/>
               </a:rPr>
               <a:t>👥 日均人次：¥15,000 ÷ ¥110客单 = 日均136人</a:t>
             </a:r>
@@ -7228,7 +7228,7 @@
                 <a:solidFill>
                   <a:srgbClr val="333333"/>
                 </a:solidFill>
-                <a:latin typeface="WenQuanYi Micro Hei"/>
+                <a:latin typeface="Microsoft YaHei"/>
               </a:rPr>
               <a:t>🪑 桌台估算：260㎡ ÷ 10㎡/桌（含通道）≈ 26桌（4-6人/桌）</a:t>
             </a:r>
@@ -7244,7 +7244,7 @@
                 <a:solidFill>
                   <a:srgbClr val="333333"/>
                 </a:solidFill>
-                <a:latin typeface="WenQuanYi Micro Hei"/>
+                <a:latin typeface="Microsoft YaHei"/>
               </a:rPr>
               <a:t>🔄 平均翻台率：136人 ÷ (26桌×4人) ≈ 1.3次/天</a:t>
             </a:r>
@@ -7260,7 +7260,7 @@
                 <a:solidFill>
                   <a:srgbClr val="333333"/>
                 </a:solidFill>
-                <a:latin typeface="WenQuanYi Micro Hei"/>
+                <a:latin typeface="Microsoft YaHei"/>
               </a:rPr>
               <a:t/>
             </a:r>
@@ -7276,7 +7276,7 @@
                 <a:solidFill>
                   <a:srgbClr val="333333"/>
                 </a:solidFill>
-                <a:latin typeface="WenQuanYi Micro Hei"/>
+                <a:latin typeface="Microsoft YaHei"/>
               </a:rPr>
               <a:t>⚠️ 关键发现：工作日 vs 周末严重失衡</a:t>
             </a:r>
@@ -7292,7 +7292,7 @@
                 <a:solidFill>
                   <a:srgbClr val="333333"/>
                 </a:solidFill>
-                <a:latin typeface="WenQuanYi Micro Hei"/>
+                <a:latin typeface="Microsoft YaHei"/>
               </a:rPr>
               <a:t>    · 周末（5天×0.6翻台×26桌×4人×¥110 = ¥34,320/天？不对）</a:t>
             </a:r>
@@ -7308,7 +7308,7 @@
                 <a:solidFill>
                   <a:srgbClr val="333333"/>
                 </a:solidFill>
-                <a:latin typeface="WenQuanYi Micro Hei"/>
+                <a:latin typeface="Microsoft YaHei"/>
               </a:rPr>
               <a:t>    · 修正：周末2天翻台2.5次 → 2×(26×4×2.5×110) = ¥57,200/天 → ¥114,400</a:t>
             </a:r>
@@ -7324,7 +7324,7 @@
                 <a:solidFill>
                   <a:srgbClr val="333333"/>
                 </a:solidFill>
-                <a:latin typeface="WenQuanYi Micro Hei"/>
+                <a:latin typeface="Microsoft YaHei"/>
               </a:rPr>
               <a:t>    · 工作日5天翻台0.7次 → 5×(26×4×0.7×110) = ¥40,040/天 → ¥200,200</a:t>
             </a:r>
@@ -7340,7 +7340,7 @@
                 <a:solidFill>
                   <a:srgbClr val="333333"/>
                 </a:solidFill>
-                <a:latin typeface="WenQuanYi Micro Hei"/>
+                <a:latin typeface="Microsoft YaHei"/>
               </a:rPr>
               <a:t>    · 周末2天+工作日5天 ≈ ¥114K+¥200K ≈ ¥314K... 偏低</a:t>
             </a:r>
@@ -7356,7 +7356,7 @@
                 <a:solidFill>
                   <a:srgbClr val="333333"/>
                 </a:solidFill>
-                <a:latin typeface="WenQuanYi Micro Hei"/>
+                <a:latin typeface="Microsoft YaHei"/>
               </a:rPr>
               <a:t/>
             </a:r>
@@ -7372,7 +7372,7 @@
                 <a:solidFill>
                   <a:srgbClr val="333333"/>
                 </a:solidFill>
-                <a:latin typeface="WenQuanYi Micro Hei"/>
+                <a:latin typeface="Microsoft YaHei"/>
               </a:rPr>
               <a:t>✅ 校准模型：周末翻台2.8次(约¥128K) + 工作日翻台0.9次(约¥322K) = ¥450K ✓</a:t>
             </a:r>
@@ -7388,7 +7388,7 @@
                 <a:solidFill>
                   <a:srgbClr val="333333"/>
                 </a:solidFill>
-                <a:latin typeface="WenQuanYi Micro Hei"/>
+                <a:latin typeface="Microsoft YaHei"/>
               </a:rPr>
               <a:t>    实际：周末日均220人 × 2天 + 工作日日均100人 × 5天 = 940人/周 ≈ 4,050人/月</a:t>
             </a:r>
@@ -7404,7 +7404,7 @@
                 <a:solidFill>
                   <a:srgbClr val="333333"/>
                 </a:solidFill>
-                <a:latin typeface="WenQuanYi Micro Hei"/>
+                <a:latin typeface="Microsoft YaHei"/>
               </a:rPr>
               <a:t>    4,050×¥110 = ¥445,500 ≈ ¥450,000 ✅ 数据自洽</a:t>
             </a:r>
@@ -7509,7 +7509,7 @@
                 <a:solidFill>
                   <a:srgbClr val="FFFFFF"/>
                 </a:solidFill>
-                <a:latin typeface="WenQuanYi Micro Hei"/>
+                <a:latin typeface="Microsoft YaHei"/>
               </a:rPr>
               <a:t>🔥 品牌理解：中高端川味火锅的机遇与挑战</a:t>
             </a:r>
@@ -7544,7 +7544,7 @@
                 <a:solidFill>
                   <a:srgbClr val="BBDEFB"/>
                 </a:solidFill>
-                <a:latin typeface="WenQuanYi Micro Hei"/>
+                <a:latin typeface="Microsoft YaHei"/>
               </a:rPr>
               <a:t>人均¥110品质火锅 × 商场3楼 × 工作日引流突破期</a:t>
             </a:r>
@@ -7579,7 +7579,7 @@
                 <a:solidFill>
                   <a:srgbClr val="E53E3E"/>
                 </a:solidFill>
-                <a:latin typeface="WenQuanYi Micro Hei"/>
+                <a:latin typeface="Microsoft YaHei"/>
               </a:rPr>
               <a:t>⚠️ 核心痛点</a:t>
             </a:r>
@@ -7618,7 +7618,7 @@
                 <a:solidFill>
                   <a:srgbClr val="333333"/>
                 </a:solidFill>
-                <a:latin typeface="WenQuanYi Micro Hei"/>
+                <a:latin typeface="Microsoft YaHei"/>
               </a:rPr>
               <a:t>• 工作日翻台仅0.9次，26桌日均空置8-10桌，每日浪费¥3,500+潜在流水</a:t>
             </a:r>
@@ -7634,7 +7634,7 @@
                 <a:solidFill>
                   <a:srgbClr val="333333"/>
                 </a:solidFill>
-                <a:latin typeface="WenQuanYi Micro Hei"/>
+                <a:latin typeface="Microsoft YaHei"/>
               </a:rPr>
               <a:t>• 周末满座但「一次性消费」占比过高，估计储值客&lt;15%（标杆应达30%+）</a:t>
             </a:r>
@@ -7650,7 +7650,7 @@
                 <a:solidFill>
                   <a:srgbClr val="333333"/>
                 </a:solidFill>
-                <a:latin typeface="WenQuanYi Micro Hei"/>
+                <a:latin typeface="Microsoft YaHei"/>
               </a:rPr>
               <a:t>• 周边¥73-99价格带火锅形成「性价比包围」，分流价格敏感客群</a:t>
             </a:r>
@@ -7666,7 +7666,7 @@
                 <a:solidFill>
                   <a:srgbClr val="333333"/>
                 </a:solidFill>
-                <a:latin typeface="WenQuanYi Micro Hei"/>
+                <a:latin typeface="Microsoft YaHei"/>
               </a:rPr>
               <a:t>• 缺少工作日消费场景设计，周边白领只知道「蜀香坊是周末聚餐去的」</a:t>
             </a:r>
@@ -7682,7 +7682,7 @@
                 <a:solidFill>
                   <a:srgbClr val="333333"/>
                 </a:solidFill>
-                <a:latin typeface="WenQuanYi Micro Hei"/>
+                <a:latin typeface="Microsoft YaHei"/>
               </a:rPr>
               <a:t>• 会员旗舰版已签但潜客营销/团购会员卡能力尚未激活</a:t>
             </a:r>
@@ -7698,7 +7698,7 @@
                 <a:solidFill>
                   <a:srgbClr val="333333"/>
                 </a:solidFill>
-                <a:latin typeface="WenQuanYi Micro Hei"/>
+                <a:latin typeface="Microsoft YaHei"/>
               </a:rPr>
               <a:t>• 评价运营缺乏系统规划，新客「搜了不敢来」转化率有提升空间</a:t>
             </a:r>
@@ -7733,7 +7733,7 @@
                 <a:solidFill>
                   <a:srgbClr val="2E7D32"/>
                 </a:solidFill>
-                <a:latin typeface="WenQuanYi Micro Hei"/>
+                <a:latin typeface="Microsoft YaHei"/>
               </a:rPr>
               <a:t>🔥 赛道机遇</a:t>
             </a:r>
@@ -7772,7 +7772,7 @@
                 <a:solidFill>
                   <a:srgbClr val="333333"/>
                 </a:solidFill>
-                <a:latin typeface="WenQuanYi Micro Hei"/>
+                <a:latin typeface="Microsoft YaHei"/>
               </a:rPr>
               <a:t>• 火锅赛道2025年规模6,500亿+，品质火锅(¥80-120)价格带最稳</a:t>
             </a:r>
@@ -7788,7 +7788,7 @@
                 <a:solidFill>
                   <a:srgbClr val="333333"/>
                 </a:solidFill>
-                <a:latin typeface="WenQuanYi Micro Hei"/>
+                <a:latin typeface="Microsoft YaHei"/>
               </a:rPr>
               <a:t>• 银隆百货3楼位置有天然聚客力（购物后就餐、电影院散场高峰）</a:t>
             </a:r>
@@ -7804,7 +7804,7 @@
                 <a:solidFill>
                   <a:srgbClr val="333333"/>
                 </a:solidFill>
-                <a:latin typeface="WenQuanYi Micro Hei"/>
+                <a:latin typeface="Microsoft YaHei"/>
               </a:rPr>
               <a:t>• 人均¥110 × 桌均¥400+ → 储值锁客天然适配（高桌均=高储值意愿）</a:t>
             </a:r>
@@ -7820,7 +7820,7 @@
                 <a:solidFill>
                   <a:srgbClr val="333333"/>
                 </a:solidFill>
-                <a:latin typeface="WenQuanYi Micro Hei"/>
+                <a:latin typeface="Microsoft YaHei"/>
               </a:rPr>
               <a:t>• 萧山市心路火锅搜索量同比+12%，品类热度仍在上升</a:t>
             </a:r>
@@ -7836,7 +7836,7 @@
                 <a:solidFill>
                   <a:srgbClr val="333333"/>
                 </a:solidFill>
-                <a:latin typeface="WenQuanYi Micro Hei"/>
+                <a:latin typeface="Microsoft YaHei"/>
               </a:rPr>
               <a:t>• 大众点评本地精选榜有空位，冲击可提升30%自然曝光</a:t>
             </a:r>
@@ -7852,7 +7852,7 @@
                 <a:solidFill>
                   <a:srgbClr val="333333"/>
                 </a:solidFill>
-                <a:latin typeface="WenQuanYi Micro Hei"/>
+                <a:latin typeface="Microsoft YaHei"/>
               </a:rPr>
               <a:t>• 已签会员旗舰版 → 团购会员卡+潜客营销+6大特有活动待释放</a:t>
             </a:r>
@@ -7957,7 +7957,7 @@
                 <a:solidFill>
                   <a:srgbClr val="FFFFFF"/>
                 </a:solidFill>
-                <a:latin typeface="WenQuanYi Micro Hei"/>
+                <a:latin typeface="Microsoft YaHei"/>
               </a:rPr>
               <a:t>🏆 竞品分析：周边3公里火锅真实对手盘</a:t>
             </a:r>
@@ -7992,7 +7992,7 @@
                 <a:solidFill>
                   <a:srgbClr val="BBDEFB"/>
                 </a:solidFill>
-                <a:latin typeface="WenQuanYi Micro Hei"/>
+                <a:latin typeface="Microsoft YaHei"/>
               </a:rPr>
               <a:t>萧山市心路商圈 · 数据来源：大众点评</a:t>
             </a:r>
@@ -8031,7 +8031,7 @@
                 <a:solidFill>
                   <a:srgbClr val="333333"/>
                 </a:solidFill>
-                <a:latin typeface="WenQuanYi Micro Hei"/>
+                <a:latin typeface="Microsoft YaHei"/>
               </a:rPr>
               <a:t>┌─────────────────────────────────────────────────────────────────────────┐</a:t>
             </a:r>
@@ -8047,7 +8047,7 @@
                 <a:solidFill>
                   <a:srgbClr val="333333"/>
                 </a:solidFill>
-                <a:latin typeface="WenQuanYi Micro Hei"/>
+                <a:latin typeface="Microsoft YaHei"/>
               </a:rPr>
               <a:t>│ 竞品名称              │ 人均  │ 评价数  │ 核心优势          │ 弱点/切入点           │</a:t>
             </a:r>
@@ -8063,7 +8063,7 @@
                 <a:solidFill>
                   <a:srgbClr val="333333"/>
                 </a:solidFill>
-                <a:latin typeface="WenQuanYi Micro Hei"/>
+                <a:latin typeface="Microsoft YaHei"/>
               </a:rPr>
               <a:t>├─────────────────────────────────────────────────────────────────────────┤</a:t>
             </a:r>
@@ -8079,7 +8079,7 @@
                 <a:solidFill>
                   <a:srgbClr val="333333"/>
                 </a:solidFill>
-                <a:latin typeface="WenQuanYi Micro Hei"/>
+                <a:latin typeface="Microsoft YaHei"/>
               </a:rPr>
               <a:t>│ 味舵主重庆火锅        │ ¥99  │ 6,554  │ 山野风+三味锅+甜品 │ 品质感弱于中高端定位   │</a:t>
             </a:r>
@@ -8095,7 +8095,7 @@
                 <a:solidFill>
                   <a:srgbClr val="333333"/>
                 </a:solidFill>
-                <a:latin typeface="WenQuanYi Micro Hei"/>
+                <a:latin typeface="Microsoft YaHei"/>
               </a:rPr>
               <a:t>│ (市心北路店)          │      │        │ 年轻客群粘性强     │ →我们打「品质食材」牌  │</a:t>
             </a:r>
@@ -8111,7 +8111,7 @@
                 <a:solidFill>
                   <a:srgbClr val="333333"/>
                 </a:solidFill>
-                <a:latin typeface="WenQuanYi Micro Hei"/>
+                <a:latin typeface="Microsoft YaHei"/>
               </a:rPr>
               <a:t>├─────────────────────────────────────────────────────────────────────────┤</a:t>
             </a:r>
@@ -8127,7 +8127,7 @@
                 <a:solidFill>
                   <a:srgbClr val="333333"/>
                 </a:solidFill>
-                <a:latin typeface="WenQuanYi Micro Hei"/>
+                <a:latin typeface="Microsoft YaHei"/>
               </a:rPr>
               <a:t>│ 黄牛道·贵州黄牛肉    │ ¥73  │12,367  │ 现切牛肉性价比王   │ 品类单一无法聚餐       │</a:t>
             </a:r>
@@ -8143,7 +8143,7 @@
                 <a:solidFill>
                   <a:srgbClr val="333333"/>
                 </a:solidFill>
-                <a:latin typeface="WenQuanYi Micro Hei"/>
+                <a:latin typeface="Microsoft YaHei"/>
               </a:rPr>
               <a:t>│ (萧山总店,市心中路)   │      │        │ 萧山必吃榜火锅     │ →我们打「聚餐多选择」 │</a:t>
             </a:r>
@@ -8159,7 +8159,7 @@
                 <a:solidFill>
                   <a:srgbClr val="333333"/>
                 </a:solidFill>
-                <a:latin typeface="WenQuanYi Micro Hei"/>
+                <a:latin typeface="Microsoft YaHei"/>
               </a:rPr>
               <a:t>├─────────────────────────────────────────────────────────────────────────┤</a:t>
             </a:r>
@@ -8175,7 +8175,7 @@
                 <a:solidFill>
                   <a:srgbClr val="333333"/>
                 </a:solidFill>
-                <a:latin typeface="WenQuanYi Micro Hei"/>
+                <a:latin typeface="Microsoft YaHei"/>
               </a:rPr>
               <a:t>│ 老秦凉都黄牛肉馆     │ ¥96  │43,774  │ 口碑深厚必吃榜     │ 环境老旧,年轻感不足   │</a:t>
             </a:r>
@@ -8191,7 +8191,7 @@
                 <a:solidFill>
                   <a:srgbClr val="333333"/>
                 </a:solidFill>
-                <a:latin typeface="WenQuanYi Micro Hei"/>
+                <a:latin typeface="Microsoft YaHei"/>
               </a:rPr>
               <a:t>│ (萧山店)             │      │        │ 本地老饕首选        │ →我们打「环境+体验」  │</a:t>
             </a:r>
@@ -8207,7 +8207,7 @@
                 <a:solidFill>
                   <a:srgbClr val="333333"/>
                 </a:solidFill>
-                <a:latin typeface="WenQuanYi Micro Hei"/>
+                <a:latin typeface="Microsoft YaHei"/>
               </a:rPr>
               <a:t>├─────────────────────────────────────────────────────────────────────────┤</a:t>
             </a:r>
@@ -8223,7 +8223,7 @@
                 <a:solidFill>
                   <a:srgbClr val="333333"/>
                 </a:solidFill>
-                <a:latin typeface="WenQuanYi Micro Hei"/>
+                <a:latin typeface="Microsoft YaHei"/>
               </a:rPr>
               <a:t>│ 章小喜鲜货火锅       │ ¥84  │ 3,432  │ 鲜切+泥炉特色      │ 客单低客群偏学生       │</a:t>
             </a:r>
@@ -8239,7 +8239,7 @@
                 <a:solidFill>
                   <a:srgbClr val="333333"/>
                 </a:solidFill>
-                <a:latin typeface="WenQuanYi Micro Hei"/>
+                <a:latin typeface="Microsoft YaHei"/>
               </a:rPr>
               <a:t>│ (建设一路店)          │      │        │ 性价比突出          │ →错位,商务聚餐定位    │</a:t>
             </a:r>
@@ -8255,7 +8255,7 @@
                 <a:solidFill>
                   <a:srgbClr val="333333"/>
                 </a:solidFill>
-                <a:latin typeface="WenQuanYi Micro Hei"/>
+                <a:latin typeface="Microsoft YaHei"/>
               </a:rPr>
               <a:t>└─────────────────────────────────────────────────────────────────────────┘</a:t>
             </a:r>
@@ -8271,7 +8271,7 @@
                 <a:solidFill>
                   <a:srgbClr val="333333"/>
                 </a:solidFill>
-                <a:latin typeface="WenQuanYi Micro Hei"/>
+                <a:latin typeface="Microsoft YaHei"/>
               </a:rPr>
               <a:t/>
             </a:r>
@@ -8287,7 +8287,7 @@
                 <a:solidFill>
                   <a:srgbClr val="333333"/>
                 </a:solidFill>
-                <a:latin typeface="WenQuanYi Micro Hei"/>
+                <a:latin typeface="Microsoft YaHei"/>
               </a:rPr>
               <a:t>💡 格局判断：周边火锅以¥70-100性价比为主，蜀香坊¥110需守住「品质+环境+聚餐场景」</a:t>
             </a:r>
@@ -8303,7 +8303,7 @@
                 <a:solidFill>
                   <a:srgbClr val="333333"/>
                 </a:solidFill>
-                <a:latin typeface="WenQuanYi Micro Hei"/>
+                <a:latin typeface="Microsoft YaHei"/>
               </a:rPr>
               <a:t>   差异化方向：不打价格战 → 打「同样人均多20块，但食材/服务/体验值这20块」</a:t>
             </a:r>
@@ -8408,7 +8408,7 @@
                 <a:solidFill>
                   <a:srgbClr val="FFFFFF"/>
                 </a:solidFill>
-                <a:latin typeface="WenQuanYi Micro Hei"/>
+                <a:latin typeface="Microsoft YaHei"/>
               </a:rPr>
               <a:t>🎯 三大核心策略</a:t>
             </a:r>
@@ -8443,7 +8443,7 @@
                 <a:solidFill>
                   <a:srgbClr val="BBDEFB"/>
                 </a:solidFill>
-                <a:latin typeface="WenQuanYi Micro Hei"/>
+                <a:latin typeface="Microsoft YaHei"/>
               </a:rPr>
               <a:t>储值锁客 × 工作日场景创造 × 公域引流闭环</a:t>
             </a:r>
@@ -8522,7 +8522,7 @@
                 <a:solidFill>
                   <a:srgbClr val="0D47A1"/>
                 </a:solidFill>
-                <a:latin typeface="WenQuanYi Micro Hei"/>
+                <a:latin typeface="Microsoft YaHei"/>
               </a:rPr>
               <a:t>🏹 策略一：储值锁客</a:t>
             </a:r>
@@ -8557,7 +8557,7 @@
                 <a:solidFill>
                   <a:srgbClr val="FF6D00"/>
                 </a:solidFill>
-                <a:latin typeface="WenQuanYi Micro Hei"/>
+                <a:latin typeface="Microsoft YaHei"/>
               </a:rPr>
               <a:t>核心KPI：将周末到店客的储值率从&lt;15%提升至35%</a:t>
             </a:r>
@@ -8592,7 +8592,7 @@
                 <a:solidFill>
                   <a:srgbClr val="666666"/>
                 </a:solidFill>
-                <a:latin typeface="WenQuanYi Micro Hei"/>
+                <a:latin typeface="Microsoft YaHei"/>
               </a:rPr>
               <a:t>目标：月新增储值80笔，储值余额池¥200K+
 手段：POS弹窗+话术+桌均¥400适配的储值档位
@@ -8673,7 +8673,7 @@
                 <a:solidFill>
                   <a:srgbClr val="0D47A1"/>
                 </a:solidFill>
-                <a:latin typeface="WenQuanYi Micro Hei"/>
+                <a:latin typeface="Microsoft YaHei"/>
               </a:rPr>
               <a:t>🏹 策略二：工作日场景创造</a:t>
             </a:r>
@@ -8708,7 +8708,7 @@
                 <a:solidFill>
                   <a:srgbClr val="FF6D00"/>
                 </a:solidFill>
-                <a:latin typeface="WenQuanYi Micro Hei"/>
+                <a:latin typeface="Microsoft YaHei"/>
               </a:rPr>
               <a:t>核心KPI：工作日翻台从0.9提升至1.3+</a:t>
             </a:r>
@@ -8743,7 +8743,7 @@
                 <a:solidFill>
                   <a:srgbClr val="666666"/>
                 </a:solidFill>
-                <a:latin typeface="WenQuanYi Micro Hei"/>
+                <a:latin typeface="Microsoft YaHei"/>
               </a:rPr>
               <a:t>目标：工作日日均从100人提升至140人
 手段：周三火锅日IP+工作日专属套餐+企业储值卡
@@ -8824,7 +8824,7 @@
                 <a:solidFill>
                   <a:srgbClr val="0D47A1"/>
                 </a:solidFill>
-                <a:latin typeface="WenQuanYi Micro Hei"/>
+                <a:latin typeface="Microsoft YaHei"/>
               </a:rPr>
               <a:t>🏹 策略三：公域引流闭环</a:t>
             </a:r>
@@ -8859,7 +8859,7 @@
                 <a:solidFill>
                   <a:srgbClr val="FF6D00"/>
                 </a:solidFill>
-                <a:latin typeface="WenQuanYi Micro Hei"/>
+                <a:latin typeface="Microsoft YaHei"/>
               </a:rPr>
               <a:t>核心KPI：点评+小红书→新客→储值→复购→好评</a:t>
             </a:r>
@@ -8894,7 +8894,7 @@
                 <a:solidFill>
                   <a:srgbClr val="666666"/>
                 </a:solidFill>
-                <a:latin typeface="WenQuanYi Micro Hei"/>
+                <a:latin typeface="Microsoft YaHei"/>
               </a:rPr>
               <a:t>目标：月新客占比从20%提升至30%，评分4.5+
 手段：团购套餐+评价运营+小红书KOC探店
@@ -9001,7 +9001,7 @@
                 <a:solidFill>
                   <a:srgbClr val="FFFFFF"/>
                 </a:solidFill>
-                <a:latin typeface="WenQuanYi Micro Hei"/>
+                <a:latin typeface="Microsoft YaHei"/>
               </a:rPr>
               <a:t>💳 储值体系设计：人均¥110×桌均¥400的最佳档位</a:t>
             </a:r>
@@ -9036,7 +9036,7 @@
                 <a:solidFill>
                   <a:srgbClr val="BBDEFB"/>
                 </a:solidFill>
-                <a:latin typeface="WenQuanYi Micro Hei"/>
+                <a:latin typeface="Microsoft YaHei"/>
               </a:rPr>
               <a:t>储值=锁客 | 等级=养客 | 两套互补</a:t>
             </a:r>
@@ -9071,7 +9071,7 @@
                 <a:solidFill>
                   <a:srgbClr val="0D47A1"/>
                 </a:solidFill>
-                <a:latin typeface="WenQuanYi Micro Hei"/>
+                <a:latin typeface="Microsoft YaHei"/>
               </a:rPr>
               <a:t>储值档位（基于桌均¥400设计）</a:t>
             </a:r>
@@ -9124,7 +9124,7 @@
                 <a:solidFill>
                   <a:srgbClr val="333333"/>
                 </a:solidFill>
-                <a:latin typeface="WenQuanYi Micro Hei"/>
+                <a:latin typeface="Microsoft YaHei"/>
               </a:rPr>
               <a:t>入门档  |  充500送50  |  到账¥550  |  ~9.1折  |  约1.2次</a:t>
             </a:r>
@@ -9135,7 +9135,7 @@
                 <a:solidFill>
                   <a:srgbClr val="666666"/>
                 </a:solidFill>
-                <a:latin typeface="WenQuanYi Micro Hei"/>
+                <a:latin typeface="Microsoft YaHei"/>
               </a:rPr>
               <a:t>   设计逻辑：降低首充门槛，试水</a:t>
             </a:r>
@@ -9188,7 +9188,7 @@
                 <a:solidFill>
                   <a:srgbClr val="FF6D00"/>
                 </a:solidFill>
-                <a:latin typeface="WenQuanYi Micro Hei"/>
+                <a:latin typeface="Microsoft YaHei"/>
               </a:rPr>
               <a:t>⭐主推档  |  充1,000送130  |  到账¥1,130  |  ~8.8折  |  约2.5次</a:t>
             </a:r>
@@ -9199,7 +9199,7 @@
                 <a:solidFill>
                   <a:srgbClr val="666666"/>
                 </a:solidFill>
-                <a:latin typeface="WenQuanYi Micro Hei"/>
+                <a:latin typeface="Microsoft YaHei"/>
               </a:rPr>
               <a:t>   设计逻辑：心理舒适区，3次内用完</a:t>
             </a:r>
@@ -9252,7 +9252,7 @@
                 <a:solidFill>
                   <a:srgbClr val="333333"/>
                 </a:solidFill>
-                <a:latin typeface="WenQuanYi Micro Hei"/>
+                <a:latin typeface="Microsoft YaHei"/>
               </a:rPr>
               <a:t>高价值  |  充2,000送300  |  到账¥2,300  |  ~8.7折  |  约5次</a:t>
             </a:r>
@@ -9263,7 +9263,7 @@
                 <a:solidFill>
                   <a:srgbClr val="666666"/>
                 </a:solidFill>
-                <a:latin typeface="WenQuanYi Micro Hei"/>
+                <a:latin typeface="Microsoft YaHei"/>
               </a:rPr>
               <a:t>   设计逻辑：锁定月均来2次的老客</a:t>
             </a:r>
@@ -9316,7 +9316,7 @@
                 <a:solidFill>
                   <a:srgbClr val="333333"/>
                 </a:solidFill>
-                <a:latin typeface="WenQuanYi Micro Hei"/>
+                <a:latin typeface="Microsoft YaHei"/>
               </a:rPr>
               <a:t>SVIP  |  充5,000送880  |  到账¥5,880  |  ~8.5折  |  约13次</a:t>
             </a:r>
@@ -9327,7 +9327,7 @@
                 <a:solidFill>
                   <a:srgbClr val="666666"/>
                 </a:solidFill>
-                <a:latin typeface="WenQuanYi Micro Hei"/>
+                <a:latin typeface="Microsoft YaHei"/>
               </a:rPr>
               <a:t>   设计逻辑：商务/包厢客专属</a:t>
             </a:r>
@@ -9362,7 +9362,7 @@
                 <a:solidFill>
                   <a:srgbClr val="0D47A1"/>
                 </a:solidFill>
-                <a:latin typeface="WenQuanYi Micro Hei"/>
+                <a:latin typeface="Microsoft YaHei"/>
               </a:rPr>
               <a:t>会员等级体系</a:t>
             </a:r>
@@ -9401,7 +9401,7 @@
                 <a:solidFill>
                   <a:srgbClr val="333333"/>
                 </a:solidFill>
-                <a:latin typeface="WenQuanYi Micro Hei"/>
+                <a:latin typeface="Microsoft YaHei"/>
               </a:rPr>
               <a:t>🥉 银卡：扫码即入会，享会员价锅底减¥5</a:t>
             </a:r>
@@ -9417,7 +9417,7 @@
                 <a:solidFill>
                   <a:srgbClr val="333333"/>
                 </a:solidFill>
-                <a:latin typeface="WenQuanYi Micro Hei"/>
+                <a:latin typeface="Microsoft YaHei"/>
               </a:rPr>
               <a:t>🥇 金卡：累计消费¥2,000升级，9.5折+生日双倍积分</a:t>
             </a:r>
@@ -9433,7 +9433,7 @@
                 <a:solidFill>
                   <a:srgbClr val="333333"/>
                 </a:solidFill>
-                <a:latin typeface="WenQuanYi Micro Hei"/>
+                <a:latin typeface="Microsoft YaHei"/>
               </a:rPr>
               <a:t>💎 钻石：累计¥8,000升级，9折+免费锅底+专属预约</a:t>
             </a:r>
@@ -9449,7 +9449,7 @@
                 <a:solidFill>
                   <a:srgbClr val="333333"/>
                 </a:solidFill>
-                <a:latin typeface="WenQuanYi Micro Hei"/>
+                <a:latin typeface="Microsoft YaHei"/>
               </a:rPr>
               <a:t/>
             </a:r>
@@ -9465,7 +9465,7 @@
                 <a:solidFill>
                   <a:srgbClr val="333333"/>
                 </a:solidFill>
-                <a:latin typeface="WenQuanYi Micro Hei"/>
+                <a:latin typeface="Microsoft YaHei"/>
               </a:rPr>
               <a:t>储值×等级联动：</a:t>
             </a:r>
@@ -9481,7 +9481,7 @@
                 <a:solidFill>
                   <a:srgbClr val="333333"/>
                 </a:solidFill>
-                <a:latin typeface="WenQuanYi Micro Hei"/>
+                <a:latin typeface="Microsoft YaHei"/>
               </a:rPr>
               <a:t>  · 储值消费同步累积等级经验</a:t>
             </a:r>
@@ -9497,7 +9497,7 @@
                 <a:solidFill>
                   <a:srgbClr val="333333"/>
                 </a:solidFill>
-                <a:latin typeface="WenQuanYi Micro Hei"/>
+                <a:latin typeface="Microsoft YaHei"/>
               </a:rPr>
               <a:t>  · 钻石专享储值加赠(充1000多送¥20)</a:t>
             </a:r>
@@ -9513,7 +9513,7 @@
                 <a:solidFill>
                   <a:srgbClr val="333333"/>
                 </a:solidFill>
-                <a:latin typeface="WenQuanYi Micro Hei"/>
+                <a:latin typeface="Microsoft YaHei"/>
               </a:rPr>
               <a:t>  · 生日月储值翻倍赠送</a:t>
             </a:r>
@@ -9529,7 +9529,7 @@
                 <a:solidFill>
                   <a:srgbClr val="333333"/>
                 </a:solidFill>
-                <a:latin typeface="WenQuanYi Micro Hei"/>
+                <a:latin typeface="Microsoft YaHei"/>
               </a:rPr>
               <a:t/>
             </a:r>
@@ -9545,7 +9545,7 @@
                 <a:solidFill>
                   <a:srgbClr val="333333"/>
                 </a:solidFill>
-                <a:latin typeface="WenQuanYi Micro Hei"/>
+                <a:latin typeface="Microsoft YaHei"/>
               </a:rPr>
               <a:t>首月目标：新增储值80笔 × 主推¥1,000档 = ¥80,000</a:t>
             </a:r>
@@ -9561,7 +9561,7 @@
                 <a:solidFill>
                   <a:srgbClr val="333333"/>
                 </a:solidFill>
-                <a:latin typeface="WenQuanYi Micro Hei"/>
+                <a:latin typeface="Microsoft YaHei"/>
               </a:rPr>
               <a:t>3月目标：储值余额池突破¥200,000</a:t>
             </a:r>
@@ -9666,7 +9666,7 @@
                 <a:solidFill>
                   <a:srgbClr val="FFFFFF"/>
                 </a:solidFill>
-                <a:latin typeface="WenQuanYi Micro Hei"/>
+                <a:latin typeface="Microsoft YaHei"/>
               </a:rPr>
               <a:t>📅 工作日引流：创造周一到周五吃火锅的理由</a:t>
             </a:r>
@@ -9701,7 +9701,7 @@
                 <a:solidFill>
                   <a:srgbClr val="BBDEFB"/>
                 </a:solidFill>
-                <a:latin typeface="WenQuanYi Micro Hei"/>
+                <a:latin typeface="Microsoft YaHei"/>
               </a:rPr>
               <a:t>从日均100人提升至140人 · +¥4,400/天 · +¥66,000/月</a:t>
             </a:r>
@@ -9740,7 +9740,7 @@
                 <a:solidFill>
                   <a:srgbClr val="333333"/>
                 </a:solidFill>
-                <a:latin typeface="WenQuanYi Micro Hei"/>
+                <a:latin typeface="Microsoft YaHei"/>
               </a:rPr>
               <a:t>🔸 A.「周三火锅日」固定IP</a:t>
             </a:r>
@@ -9756,7 +9756,7 @@
                 <a:solidFill>
                   <a:srgbClr val="333333"/>
                 </a:solidFill>
-                <a:latin typeface="WenQuanYi Micro Hei"/>
+                <a:latin typeface="Microsoft YaHei"/>
               </a:rPr>
               <a:t>    储值客周三到店：锅底8折（让利约¥8-12/桌），系统自动周二推送提醒</a:t>
             </a:r>
@@ -9772,7 +9772,7 @@
                 <a:solidFill>
                   <a:srgbClr val="333333"/>
                 </a:solidFill>
-                <a:latin typeface="WenQuanYi Micro Hei"/>
+                <a:latin typeface="Microsoft YaHei"/>
               </a:rPr>
               <a:t>    目标：周三翻台1.5+（从70人提升至110人/天）</a:t>
             </a:r>
@@ -9788,7 +9788,7 @@
                 <a:solidFill>
                   <a:srgbClr val="333333"/>
                 </a:solidFill>
-                <a:latin typeface="WenQuanYi Micro Hei"/>
+                <a:latin typeface="Microsoft YaHei"/>
               </a:rPr>
               <a:t/>
             </a:r>
@@ -9804,7 +9804,7 @@
                 <a:solidFill>
                   <a:srgbClr val="333333"/>
                 </a:solidFill>
-                <a:latin typeface="WenQuanYi Micro Hei"/>
+                <a:latin typeface="Microsoft YaHei"/>
               </a:rPr>
               <a:t>🔸 B. 工作日商务套餐（仅周一至五，大众点评上线团购）</a:t>
             </a:r>
@@ -9820,7 +9820,7 @@
                 <a:solidFill>
                   <a:srgbClr val="333333"/>
                 </a:solidFill>
-                <a:latin typeface="WenQuanYi Micro Hei"/>
+                <a:latin typeface="Microsoft YaHei"/>
               </a:rPr>
               <a:t>    「3人小聚」¥299：招牌锅底+5荤3素+饮品（原价¥380，省¥81）</a:t>
             </a:r>
@@ -9836,7 +9836,7 @@
                 <a:solidFill>
                   <a:srgbClr val="333333"/>
                 </a:solidFill>
-                <a:latin typeface="WenQuanYi Micro Hei"/>
+                <a:latin typeface="Microsoft YaHei"/>
               </a:rPr>
               <a:t>    「6人商务宴」¥599：鸳鸯锅+8荤5素+啤酒6瓶（原价¥750，省¥151）</a:t>
             </a:r>
@@ -9852,7 +9852,7 @@
                 <a:solidFill>
                   <a:srgbClr val="333333"/>
                 </a:solidFill>
-                <a:latin typeface="WenQuanYi Micro Hei"/>
+                <a:latin typeface="Microsoft YaHei"/>
               </a:rPr>
               <a:t>    定位：银隆百货商户/市心路写字楼「工作日聚餐首选」</a:t>
             </a:r>
@@ -9868,7 +9868,7 @@
                 <a:solidFill>
                   <a:srgbClr val="333333"/>
                 </a:solidFill>
-                <a:latin typeface="WenQuanYi Micro Hei"/>
+                <a:latin typeface="Microsoft YaHei"/>
               </a:rPr>
               <a:t/>
             </a:r>
@@ -9884,7 +9884,7 @@
                 <a:solidFill>
                   <a:srgbClr val="333333"/>
                 </a:solidFill>
-                <a:latin typeface="WenQuanYi Micro Hei"/>
+                <a:latin typeface="Microsoft YaHei"/>
               </a:rPr>
               <a:t>🔸 C. 企业储值卡（专攻B端）</a:t>
             </a:r>
@@ -9900,7 +9900,7 @@
                 <a:solidFill>
                   <a:srgbClr val="333333"/>
                 </a:solidFill>
-                <a:latin typeface="WenQuanYi Micro Hei"/>
+                <a:latin typeface="Microsoft YaHei"/>
               </a:rPr>
               <a:t>    企业卡充¥5,000送¥1,000，可多人使用，锁定团建/商务宴请</a:t>
             </a:r>
@@ -9916,7 +9916,7 @@
                 <a:solidFill>
                   <a:srgbClr val="333333"/>
                 </a:solidFill>
-                <a:latin typeface="WenQuanYi Micro Hei"/>
+                <a:latin typeface="Microsoft YaHei"/>
               </a:rPr>
               <a:t>    目标：首月签约5家企业 × ¥5,000 = ¥25,000储值入账</a:t>
             </a:r>
@@ -9932,7 +9932,7 @@
                 <a:solidFill>
                   <a:srgbClr val="333333"/>
                 </a:solidFill>
-                <a:latin typeface="WenQuanYi Micro Hei"/>
+                <a:latin typeface="Microsoft YaHei"/>
               </a:rPr>
               <a:t/>
             </a:r>
@@ -9948,7 +9948,7 @@
                 <a:solidFill>
                   <a:srgbClr val="333333"/>
                 </a:solidFill>
-                <a:latin typeface="WenQuanYi Micro Hei"/>
+                <a:latin typeface="Microsoft YaHei"/>
               </a:rPr>
               <a:t>🔸 D. 储值客工作日专属权益</a:t>
             </a:r>
@@ -9964,7 +9964,7 @@
                 <a:solidFill>
                   <a:srgbClr val="333333"/>
                 </a:solidFill>
-                <a:latin typeface="WenQuanYi Micro Hei"/>
+                <a:latin typeface="Microsoft YaHei"/>
               </a:rPr>
               <a:t>    工作日到店免费升级锅底（普通→菌汤/番茄，成本¥5-8）</a:t>
             </a:r>
@@ -9980,7 +9980,7 @@
                 <a:solidFill>
                   <a:srgbClr val="333333"/>
                 </a:solidFill>
-                <a:latin typeface="WenQuanYi Micro Hei"/>
+                <a:latin typeface="Microsoft YaHei"/>
               </a:rPr>
               <a:t>    制造「工作日来更划算」心理：周末充钱，工作日享受</a:t>
             </a:r>
@@ -9996,7 +9996,7 @@
                 <a:solidFill>
                   <a:srgbClr val="333333"/>
                 </a:solidFill>
-                <a:latin typeface="WenQuanYi Micro Hei"/>
+                <a:latin typeface="Microsoft YaHei"/>
               </a:rPr>
               <a:t/>
             </a:r>
@@ -10012,7 +10012,7 @@
                 <a:solidFill>
                   <a:srgbClr val="333333"/>
                 </a:solidFill>
-                <a:latin typeface="WenQuanYi Micro Hei"/>
+                <a:latin typeface="Microsoft YaHei"/>
               </a:rPr>
               <a:t>📊 综合效果：工作日日均从100人→140人，月增流水 40人×¥110×22天 = ¥96,800</a:t>
             </a:r>
@@ -10028,7 +10028,7 @@
                 <a:solidFill>
                   <a:srgbClr val="333333"/>
                 </a:solidFill>
-                <a:latin typeface="WenQuanYi Micro Hei"/>
+                <a:latin typeface="Microsoft YaHei"/>
               </a:rPr>
               <a:t>    保守按60%转化：月增约¥58,000</a:t>
             </a:r>
@@ -10133,7 +10133,7 @@
                 <a:solidFill>
                   <a:srgbClr val="FFFFFF"/>
                 </a:solidFill>
-                <a:latin typeface="WenQuanYi Micro Hei"/>
+                <a:latin typeface="Microsoft YaHei"/>
               </a:rPr>
               <a:t>🌐 公私域联动闭环：新客从哪来，老客怎么留</a:t>
             </a:r>
@@ -10168,7 +10168,7 @@
                 <a:solidFill>
                   <a:srgbClr val="BBDEFB"/>
                 </a:solidFill>
-                <a:latin typeface="WenQuanYi Micro Hei"/>
+                <a:latin typeface="Microsoft YaHei"/>
               </a:rPr>
               <a:t>公域拉新 → 到店体验 → 私域锁定 → 复购好评 → 公域放大</a:t>
             </a:r>
@@ -10207,7 +10207,7 @@
                 <a:solidFill>
                   <a:srgbClr val="333333"/>
                 </a:solidFill>
-                <a:latin typeface="WenQuanYi Micro Hei"/>
+                <a:latin typeface="Microsoft YaHei"/>
               </a:rPr>
               <a:t>━━━━━━━━━━━━━━━━━━ 完整闭环 ━━━━━━━━━━━━━━━━━━</a:t>
             </a:r>
@@ -10223,7 +10223,7 @@
                 <a:solidFill>
                   <a:srgbClr val="333333"/>
                 </a:solidFill>
-                <a:latin typeface="WenQuanYi Micro Hei"/>
+                <a:latin typeface="Microsoft YaHei"/>
               </a:rPr>
               <a:t/>
             </a:r>
@@ -10239,7 +10239,7 @@
                 <a:solidFill>
                   <a:srgbClr val="333333"/>
                 </a:solidFill>
-                <a:latin typeface="WenQuanYi Micro Hei"/>
+                <a:latin typeface="Microsoft YaHei"/>
               </a:rPr>
               <a:t>【公域引流】                  【到店转化】              【私域锁定】              【循环放大】</a:t>
             </a:r>
@@ -10255,7 +10255,7 @@
                 <a:solidFill>
                   <a:srgbClr val="333333"/>
                 </a:solidFill>
-                <a:latin typeface="WenQuanYi Micro Hei"/>
+                <a:latin typeface="Microsoft YaHei"/>
               </a:rPr>
               <a:t>大众点评团购套餐 ──────→  扫码点餐自动入会 ────→  结账推储值(POS弹窗) ───→ 储值客贡献好评</a:t>
             </a:r>
@@ -10271,7 +10271,7 @@
                 <a:solidFill>
                   <a:srgbClr val="333333"/>
                 </a:solidFill>
-                <a:latin typeface="WenQuanYi Micro Hei"/>
+                <a:latin typeface="Microsoft YaHei"/>
               </a:rPr>
               <a:t>小红书KOC探店笔记 ─────→  首次体验峰值设计 ────→  会员等级累积       ───→ 好评提升排名</a:t>
             </a:r>
@@ -10287,7 +10287,7 @@
                 <a:solidFill>
                   <a:srgbClr val="333333"/>
                 </a:solidFill>
-                <a:latin typeface="WenQuanYi Micro Hei"/>
+                <a:latin typeface="Microsoft YaHei"/>
               </a:rPr>
               <a:t>点评评分维护4.5+ ──────→  好评引导(评价专家) ──→  沉睡唤醒自动触达   ───→ 更多新客搜到</a:t>
             </a:r>
@@ -10303,7 +10303,7 @@
                 <a:solidFill>
                   <a:srgbClr val="333333"/>
                 </a:solidFill>
-                <a:latin typeface="WenQuanYi Micro Hei"/>
+                <a:latin typeface="Microsoft YaHei"/>
               </a:rPr>
               <a:t/>
             </a:r>
@@ -10319,7 +10319,7 @@
                 <a:solidFill>
                   <a:srgbClr val="333333"/>
                 </a:solidFill>
-                <a:latin typeface="WenQuanYi Micro Hei"/>
+                <a:latin typeface="Microsoft YaHei"/>
               </a:rPr>
               <a:t>━━━━━━━━━━━━━━━━━━━━━━━━━━━━━━━━━━━━━━━━━━━━━━━━━━━</a:t>
             </a:r>
@@ -10354,7 +10354,7 @@
                 <a:solidFill>
                   <a:srgbClr val="1A73E8"/>
                 </a:solidFill>
-                <a:latin typeface="WenQuanYi Micro Hei"/>
+                <a:latin typeface="Microsoft YaHei"/>
               </a:rPr>
               <a:t>📱 公域：大众点评</a:t>
             </a:r>
@@ -10393,7 +10393,7 @@
                 <a:solidFill>
                   <a:srgbClr val="333333"/>
                 </a:solidFill>
-                <a:latin typeface="WenQuanYi Micro Hei"/>
+                <a:latin typeface="Microsoft YaHei"/>
               </a:rPr>
               <a:t>• 上线工作日团购套餐(¥299/¥599)</a:t>
             </a:r>
@@ -10409,7 +10409,7 @@
                 <a:solidFill>
                   <a:srgbClr val="333333"/>
                 </a:solidFill>
-                <a:latin typeface="WenQuanYi Micro Hei"/>
+                <a:latin typeface="Microsoft YaHei"/>
               </a:rPr>
               <a:t>• 冲击本地精选榜(评分4.5+目标)</a:t>
             </a:r>
@@ -10425,7 +10425,7 @@
                 <a:solidFill>
                   <a:srgbClr val="333333"/>
                 </a:solidFill>
-                <a:latin typeface="WenQuanYi Micro Hei"/>
+                <a:latin typeface="Microsoft YaHei"/>
               </a:rPr>
               <a:t>• 评价运营：首10条定调+引导好评</a:t>
             </a:r>
@@ -10441,7 +10441,7 @@
                 <a:solidFill>
                   <a:srgbClr val="333333"/>
                 </a:solidFill>
-                <a:latin typeface="WenQuanYi Micro Hei"/>
+                <a:latin typeface="Microsoft YaHei"/>
               </a:rPr>
               <a:t>• 搜索关键词优化：萧山火锅/市心路火锅</a:t>
             </a:r>
@@ -10457,7 +10457,7 @@
                 <a:solidFill>
                   <a:srgbClr val="333333"/>
                 </a:solidFill>
-                <a:latin typeface="WenQuanYi Micro Hei"/>
+                <a:latin typeface="Microsoft YaHei"/>
               </a:rPr>
               <a:t>• 月预算：推广通¥1,500/月</a:t>
             </a:r>
@@ -10492,7 +10492,7 @@
                 <a:solidFill>
                   <a:srgbClr val="1A73E8"/>
                 </a:solidFill>
-                <a:latin typeface="WenQuanYi Micro Hei"/>
+                <a:latin typeface="Microsoft YaHei"/>
               </a:rPr>
               <a:t>📸 公域：小红书</a:t>
             </a:r>
@@ -10531,7 +10531,7 @@
                 <a:solidFill>
                   <a:srgbClr val="333333"/>
                 </a:solidFill>
-                <a:latin typeface="WenQuanYi Micro Hei"/>
+                <a:latin typeface="Microsoft YaHei"/>
               </a:rPr>
               <a:t>• 每月4篇KOC探店笔记(置换免费)</a:t>
             </a:r>
@@ -10547,7 +10547,7 @@
                 <a:solidFill>
                   <a:srgbClr val="333333"/>
                 </a:solidFill>
-                <a:latin typeface="WenQuanYi Micro Hei"/>
+                <a:latin typeface="Microsoft YaHei"/>
               </a:rPr>
               <a:t>• 内容方向：锅底特色+聚餐氛围+出片场景</a:t>
             </a:r>
@@ -10563,7 +10563,7 @@
                 <a:solidFill>
                   <a:srgbClr val="333333"/>
                 </a:solidFill>
-                <a:latin typeface="WenQuanYi Micro Hei"/>
+                <a:latin typeface="Microsoft YaHei"/>
               </a:rPr>
               <a:t>• 关键词：萧山火锅/银隆百货美食/市心路聚餐</a:t>
             </a:r>
@@ -10579,7 +10579,7 @@
                 <a:solidFill>
                   <a:srgbClr val="333333"/>
                 </a:solidFill>
-                <a:latin typeface="WenQuanYi Micro Hei"/>
+                <a:latin typeface="Microsoft YaHei"/>
               </a:rPr>
               <a:t>• 配合新品/节日活动同步发布</a:t>
             </a:r>
@@ -10595,7 +10595,7 @@
                 <a:solidFill>
                   <a:srgbClr val="333333"/>
                 </a:solidFill>
-                <a:latin typeface="WenQuanYi Micro Hei"/>
+                <a:latin typeface="Microsoft YaHei"/>
               </a:rPr>
               <a:t>• 月预算：¥800(4位KOC×¥200餐费)</a:t>
             </a:r>
@@ -10630,7 +10630,7 @@
                 <a:solidFill>
                   <a:srgbClr val="1A73E8"/>
                 </a:solidFill>
-                <a:latin typeface="WenQuanYi Micro Hei"/>
+                <a:latin typeface="Microsoft YaHei"/>
               </a:rPr>
               <a:t>🔒 私域：会员系统</a:t>
             </a:r>
@@ -10669,7 +10669,7 @@
                 <a:solidFill>
                   <a:srgbClr val="333333"/>
                 </a:solidFill>
-                <a:latin typeface="WenQuanYi Micro Hei"/>
+                <a:latin typeface="Microsoft YaHei"/>
               </a:rPr>
               <a:t>• 扫码点餐=自动入会(零打扰)</a:t>
             </a:r>
@@ -10685,7 +10685,7 @@
                 <a:solidFill>
                   <a:srgbClr val="333333"/>
                 </a:solidFill>
-                <a:latin typeface="WenQuanYi Micro Hei"/>
+                <a:latin typeface="Microsoft YaHei"/>
               </a:rPr>
               <a:t>• 结账POS弹窗推储值(主推¥1,000档)</a:t>
             </a:r>
@@ -10701,7 +10701,7 @@
                 <a:solidFill>
                   <a:srgbClr val="333333"/>
                 </a:solidFill>
-                <a:latin typeface="WenQuanYi Micro Hei"/>
+                <a:latin typeface="Microsoft YaHei"/>
               </a:rPr>
               <a:t>• 15天未到店自动发唤醒券(¥30抵用)</a:t>
             </a:r>
@@ -10717,7 +10717,7 @@
                 <a:solidFill>
                   <a:srgbClr val="333333"/>
                 </a:solidFill>
-                <a:latin typeface="WenQuanYi Micro Hei"/>
+                <a:latin typeface="Microsoft YaHei"/>
               </a:rPr>
               <a:t>• 周二自动推送「周三火锅日」提醒</a:t>
             </a:r>
@@ -10733,7 +10733,7 @@
                 <a:solidFill>
                   <a:srgbClr val="333333"/>
                 </a:solidFill>
-                <a:latin typeface="WenQuanYi Micro Hei"/>
+                <a:latin typeface="Microsoft YaHei"/>
               </a:rPr>
               <a:t>• 生日月自动发专属礼(免费锅底升级)</a:t>
             </a:r>
@@ -10838,7 +10838,7 @@
                 <a:solidFill>
                   <a:srgbClr val="FFFFFF"/>
                 </a:solidFill>
-                <a:latin typeface="WenQuanYi Micro Hei"/>
+                <a:latin typeface="Microsoft YaHei"/>
               </a:rPr>
               <a:t>📆 营销节奏：首季度12周执行排期</a:t>
             </a:r>
@@ -10873,7 +10873,7 @@
                 <a:solidFill>
                   <a:srgbClr val="BBDEFB"/>
                 </a:solidFill>
-                <a:latin typeface="WenQuanYi Micro Hei"/>
+                <a:latin typeface="Microsoft YaHei"/>
               </a:rPr>
               <a:t>按周落地，每周一个重点动作</a:t>
             </a:r>
@@ -10912,7 +10912,7 @@
                 <a:solidFill>
                   <a:srgbClr val="333333"/>
                 </a:solidFill>
-                <a:latin typeface="WenQuanYi Micro Hei"/>
+                <a:latin typeface="Microsoft YaHei"/>
               </a:rPr>
               <a:t>【第1-2周：基建期】蓄水+系统配置</a:t>
             </a:r>
@@ -10928,7 +10928,7 @@
                 <a:solidFill>
                   <a:srgbClr val="333333"/>
                 </a:solidFill>
-                <a:latin typeface="WenQuanYi Micro Hei"/>
+                <a:latin typeface="Microsoft YaHei"/>
               </a:rPr>
               <a:t>  W1: 会员旗舰版后台配置储值档位/等级规则/自动触达规则</a:t>
             </a:r>
@@ -10944,7 +10944,7 @@
                 <a:solidFill>
                   <a:srgbClr val="333333"/>
                 </a:solidFill>
-                <a:latin typeface="WenQuanYi Micro Hei"/>
+                <a:latin typeface="Microsoft YaHei"/>
               </a:rPr>
               <a:t>  W2: 上线大众点评团购套餐(工作日3人/6人套餐)+员工话术培训</a:t>
             </a:r>
@@ -10960,7 +10960,7 @@
                 <a:solidFill>
                   <a:srgbClr val="333333"/>
                 </a:solidFill>
-                <a:latin typeface="WenQuanYi Micro Hei"/>
+                <a:latin typeface="Microsoft YaHei"/>
               </a:rPr>
               <a:t/>
             </a:r>
@@ -10976,7 +10976,7 @@
                 <a:solidFill>
                   <a:srgbClr val="333333"/>
                 </a:solidFill>
-                <a:latin typeface="WenQuanYi Micro Hei"/>
+                <a:latin typeface="Microsoft YaHei"/>
               </a:rPr>
               <a:t>【第3-4周：启动期】小范围测试+调优</a:t>
             </a:r>
@@ -10992,7 +10992,7 @@
                 <a:solidFill>
                   <a:srgbClr val="333333"/>
                 </a:solidFill>
-                <a:latin typeface="WenQuanYi Micro Hei"/>
+                <a:latin typeface="Microsoft YaHei"/>
               </a:rPr>
               <a:t>  W3: 正式启动储值推荐(结账POS弹窗)，目标首周储值20笔</a:t>
             </a:r>
@@ -11008,7 +11008,7 @@
                 <a:solidFill>
                   <a:srgbClr val="333333"/>
                 </a:solidFill>
-                <a:latin typeface="WenQuanYi Micro Hei"/>
+                <a:latin typeface="Microsoft YaHei"/>
               </a:rPr>
               <a:t>  W4: 「周三火锅日」首次落地，监测周三客流变化</a:t>
             </a:r>
@@ -11024,7 +11024,7 @@
                 <a:solidFill>
                   <a:srgbClr val="333333"/>
                 </a:solidFill>
-                <a:latin typeface="WenQuanYi Micro Hei"/>
+                <a:latin typeface="Microsoft YaHei"/>
               </a:rPr>
               <a:t/>
             </a:r>
@@ -11040,7 +11040,7 @@
                 <a:solidFill>
                   <a:srgbClr val="333333"/>
                 </a:solidFill>
-                <a:latin typeface="WenQuanYi Micro Hei"/>
+                <a:latin typeface="Microsoft YaHei"/>
               </a:rPr>
               <a:t>【第5-8周：爆发期】全渠道发力</a:t>
             </a:r>
@@ -11056,7 +11056,7 @@
                 <a:solidFill>
                   <a:srgbClr val="333333"/>
                 </a:solidFill>
-                <a:latin typeface="WenQuanYi Micro Hei"/>
+                <a:latin typeface="Microsoft YaHei"/>
               </a:rPr>
               <a:t>  W5: 首批小红书探店笔记发布(2篇)，点评评价引导系统开启</a:t>
             </a:r>
@@ -11072,7 +11072,7 @@
                 <a:solidFill>
                   <a:srgbClr val="333333"/>
                 </a:solidFill>
-                <a:latin typeface="WenQuanYi Micro Hei"/>
+                <a:latin typeface="Microsoft YaHei"/>
               </a:rPr>
               <a:t>  W6: 企业储值卡推广(BD银隆百货商户)，目标签约3家</a:t>
             </a:r>
@@ -11088,7 +11088,7 @@
                 <a:solidFill>
                   <a:srgbClr val="333333"/>
                 </a:solidFill>
-                <a:latin typeface="WenQuanYi Micro Hei"/>
+                <a:latin typeface="Microsoft YaHei"/>
               </a:rPr>
               <a:t>  W7: 会员日活动「双倍积分周」，激活沉睡会员</a:t>
             </a:r>
@@ -11104,7 +11104,7 @@
                 <a:solidFill>
                   <a:srgbClr val="333333"/>
                 </a:solidFill>
-                <a:latin typeface="WenQuanYi Micro Hei"/>
+                <a:latin typeface="Microsoft YaHei"/>
               </a:rPr>
               <a:t>  W8: 端午节专题：「粽享火锅季」储值加赠活动(充1000送150)</a:t>
             </a:r>
@@ -11120,7 +11120,7 @@
                 <a:solidFill>
                   <a:srgbClr val="333333"/>
                 </a:solidFill>
-                <a:latin typeface="WenQuanYi Micro Hei"/>
+                <a:latin typeface="Microsoft YaHei"/>
               </a:rPr>
               <a:t/>
             </a:r>
@@ -11136,7 +11136,7 @@
                 <a:solidFill>
                   <a:srgbClr val="333333"/>
                 </a:solidFill>
-                <a:latin typeface="WenQuanYi Micro Hei"/>
+                <a:latin typeface="Microsoft YaHei"/>
               </a:rPr>
               <a:t>【第9-12周：稳增期】固化节奏+优化</a:t>
             </a:r>
@@ -11152,7 +11152,7 @@
                 <a:solidFill>
                   <a:srgbClr val="333333"/>
                 </a:solidFill>
-                <a:latin typeface="WenQuanYi Micro Hei"/>
+                <a:latin typeface="Microsoft YaHei"/>
               </a:rPr>
               <a:t>  W9: 复盘前8周数据，调整储值主推档/套餐定价</a:t>
             </a:r>
@@ -11168,7 +11168,7 @@
                 <a:solidFill>
                   <a:srgbClr val="333333"/>
                 </a:solidFill>
-                <a:latin typeface="WenQuanYi Micro Hei"/>
+                <a:latin typeface="Microsoft YaHei"/>
               </a:rPr>
               <a:t>  W10: 第二轮小红书+点评内容更新，冲击月度榜单</a:t>
             </a:r>
@@ -11184,7 +11184,7 @@
                 <a:solidFill>
                   <a:srgbClr val="333333"/>
                 </a:solidFill>
-                <a:latin typeface="WenQuanYi Micro Hei"/>
+                <a:latin typeface="Microsoft YaHei"/>
               </a:rPr>
               <a:t>  W11: 暑期预热：「毕业季火锅趴」套餐上线</a:t>
             </a:r>
@@ -11200,7 +11200,7 @@
                 <a:solidFill>
                   <a:srgbClr val="333333"/>
                 </a:solidFill>
-                <a:latin typeface="WenQuanYi Micro Hei"/>
+                <a:latin typeface="Microsoft YaHei"/>
               </a:rPr>
               <a:t>  W12: 季度复盘 → 出Q3规划</a:t>
             </a:r>

</xml_diff>